<commit_message>
Add NUC PythonSV live-debug, marketplace enrichment, MCA bank maps (GNR/SRF/CWF)
- NUC PythonSV tab: SSH-first + WinRM fallback, persistent session, auto-init unlock+refresh, output cleaner + state interpreter; password via UI (masked, not stored).
- Optional marketplace MCP enrichment (Wiki KB always; BIOS/S3M, kernel-crash, Redfish need-based).
- Reference Sources citation in reports.
- Product-aware MCA bank->unit resolver with GNR, SRF, CWF, DMR maps.
- Presentation updated (+ original backup).
</commit_message>
<xml_diff>
--- a/presentation/Auto_HSD_Analyser.pptx
+++ b/presentation/Auto_HSD_Analyser.pptx
@@ -19,6 +19,13 @@
     <p:sldId id="267" r:id="rId13"/>
     <p:sldId id="268" r:id="rId14"/>
     <p:sldId id="269" r:id="rId15"/>
+    <p:sldId id="270" r:id="rId21"/>
+    <p:sldId id="271" r:id="rId22"/>
+    <p:sldId id="272" r:id="rId23"/>
+    <p:sldId id="273" r:id="rId24"/>
+    <p:sldId id="274" r:id="rId25"/>
+    <p:sldId id="275" r:id="rId26"/>
+    <p:sldId id="276" r:id="rId27"/>
   </p:sldIdLst>
   <p:sldSz cx="12192000" cy="6858000"/>
   <p:notesSz cx="6858000" cy="9144000"/>
@@ -4314,6 +4321,2631 @@
 </p:sld>
 </file>
 
+<file path=ppt/slides/slide15.xml><?xml version="1.0" encoding="utf-8"?>
+<p:sld xmlns:a="http://schemas.openxmlformats.org/drawingml/2006/main" xmlns:p="http://schemas.openxmlformats.org/presentationml/2006/main" xmlns:r="http://schemas.openxmlformats.org/officeDocument/2006/relationships">
+  <p:cSld>
+    <p:spTree>
+      <p:nvGrpSpPr>
+        <p:cNvPr id="1" name=""/>
+        <p:cNvGrpSpPr/>
+        <p:nvPr/>
+      </p:nvGrpSpPr>
+      <p:grpSpPr/>
+      <p:sp>
+        <p:nvSpPr>
+          <p:cNvPr id="2" name="Rectangle 1"/>
+          <p:cNvSpPr/>
+          <p:nvPr/>
+        </p:nvSpPr>
+        <p:spPr>
+          <a:xfrm>
+            <a:off x="0" y="0"/>
+            <a:ext cx="12192000" cy="6858000"/>
+          </a:xfrm>
+          <a:prstGeom prst="rect">
+            <a:avLst/>
+          </a:prstGeom>
+          <a:solidFill>
+            <a:srgbClr val="1B1B2F"/>
+          </a:solidFill>
+          <a:ln>
+            <a:noFill/>
+          </a:ln>
+        </p:spPr>
+        <p:style>
+          <a:lnRef idx="1">
+            <a:schemeClr val="accent1"/>
+          </a:lnRef>
+          <a:fillRef idx="3">
+            <a:schemeClr val="accent1"/>
+          </a:fillRef>
+          <a:effectRef idx="2">
+            <a:schemeClr val="accent1"/>
+          </a:effectRef>
+          <a:fontRef idx="minor">
+            <a:schemeClr val="lt1"/>
+          </a:fontRef>
+        </p:style>
+        <p:txBody>
+          <a:bodyPr rtlCol="0" anchor="ctr"/>
+          <a:lstStyle/>
+          <a:p>
+            <a:pPr algn="ctr"/>
+          </a:p>
+        </p:txBody>
+      </p:sp>
+      <p:sp>
+        <p:nvSpPr>
+          <p:cNvPr id="3" name="TextBox 2"/>
+          <p:cNvSpPr txBox="1"/>
+          <p:nvPr/>
+        </p:nvSpPr>
+        <p:spPr>
+          <a:xfrm>
+            <a:off x="822960" y="2377440"/>
+            <a:ext cx="10607040" cy="2011680"/>
+          </a:xfrm>
+          <a:prstGeom prst="rect">
+            <a:avLst/>
+          </a:prstGeom>
+          <a:noFill/>
+        </p:spPr>
+        <p:txBody>
+          <a:bodyPr wrap="square">
+            <a:spAutoFit/>
+          </a:bodyPr>
+          <a:lstStyle/>
+          <a:p>
+            <a:pPr>
+              <a:defRPr sz="4600" b="1">
+                <a:solidFill>
+                  <a:srgbClr val="FFFFFF"/>
+                </a:solidFill>
+              </a:defRPr>
+            </a:pPr>
+            <a:r>
+              <a:t>HSDES NEXUS — What's New</a:t>
+            </a:r>
+          </a:p>
+          <a:p>
+            <a:pPr>
+              <a:defRPr sz="2000">
+                <a:solidFill>
+                  <a:srgbClr val="8EC5F0"/>
+                </a:solidFill>
+              </a:defRPr>
+            </a:pPr>
+            <a:r>
+              <a:t>PythonSV Live Debug via NUC  ·  Marketplace enrichment  ·  Reference Sources</a:t>
+            </a:r>
+          </a:p>
+        </p:txBody>
+      </p:sp>
+      <p:sp>
+        <p:nvSpPr>
+          <p:cNvPr id="4" name="Rectangle 3"/>
+          <p:cNvSpPr/>
+          <p:nvPr/>
+        </p:nvSpPr>
+        <p:spPr>
+          <a:xfrm>
+            <a:off x="0" y="6309360"/>
+            <a:ext cx="12192000" cy="548640"/>
+          </a:xfrm>
+          <a:prstGeom prst="rect">
+            <a:avLst/>
+          </a:prstGeom>
+          <a:solidFill>
+            <a:srgbClr val="0071C5"/>
+          </a:solidFill>
+          <a:ln>
+            <a:noFill/>
+          </a:ln>
+        </p:spPr>
+        <p:style>
+          <a:lnRef idx="1">
+            <a:schemeClr val="accent1"/>
+          </a:lnRef>
+          <a:fillRef idx="3">
+            <a:schemeClr val="accent1"/>
+          </a:fillRef>
+          <a:effectRef idx="2">
+            <a:schemeClr val="accent1"/>
+          </a:effectRef>
+          <a:fontRef idx="minor">
+            <a:schemeClr val="lt1"/>
+          </a:fontRef>
+        </p:style>
+        <p:txBody>
+          <a:bodyPr rtlCol="0" anchor="ctr"/>
+          <a:lstStyle/>
+          <a:p>
+            <a:pPr algn="ctr"/>
+          </a:p>
+        </p:txBody>
+      </p:sp>
+    </p:spTree>
+  </p:cSld>
+  <p:clrMapOvr>
+    <a:masterClrMapping/>
+  </p:clrMapOvr>
+</p:sld>
+</file>
+
+<file path=ppt/slides/slide16.xml><?xml version="1.0" encoding="utf-8"?>
+<p:sld xmlns:a="http://schemas.openxmlformats.org/drawingml/2006/main" xmlns:p="http://schemas.openxmlformats.org/presentationml/2006/main" xmlns:r="http://schemas.openxmlformats.org/officeDocument/2006/relationships">
+  <p:cSld>
+    <p:spTree>
+      <p:nvGrpSpPr>
+        <p:cNvPr id="1" name=""/>
+        <p:cNvGrpSpPr/>
+        <p:nvPr/>
+      </p:nvGrpSpPr>
+      <p:grpSpPr/>
+      <p:sp>
+        <p:nvSpPr>
+          <p:cNvPr id="2" name="Rectangle 1"/>
+          <p:cNvSpPr/>
+          <p:nvPr/>
+        </p:nvSpPr>
+        <p:spPr>
+          <a:xfrm>
+            <a:off x="0" y="0"/>
+            <a:ext cx="12192000" cy="960120"/>
+          </a:xfrm>
+          <a:prstGeom prst="rect">
+            <a:avLst/>
+          </a:prstGeom>
+          <a:solidFill>
+            <a:srgbClr val="0071C5"/>
+          </a:solidFill>
+          <a:ln>
+            <a:noFill/>
+          </a:ln>
+        </p:spPr>
+        <p:style>
+          <a:lnRef idx="1">
+            <a:schemeClr val="accent1"/>
+          </a:lnRef>
+          <a:fillRef idx="3">
+            <a:schemeClr val="accent1"/>
+          </a:fillRef>
+          <a:effectRef idx="2">
+            <a:schemeClr val="accent1"/>
+          </a:effectRef>
+          <a:fontRef idx="minor">
+            <a:schemeClr val="lt1"/>
+          </a:fontRef>
+        </p:style>
+        <p:txBody>
+          <a:bodyPr rtlCol="0" anchor="ctr" lIns="365760" wrap="square"/>
+          <a:lstStyle/>
+          <a:p>
+            <a:pPr algn="ctr">
+              <a:defRPr sz="3000" b="1">
+                <a:solidFill>
+                  <a:srgbClr val="FFFFFF"/>
+                </a:solidFill>
+              </a:defRPr>
+            </a:pPr>
+            <a:r>
+              <a:t>What is HSDES NEXUS?</a:t>
+            </a:r>
+          </a:p>
+          <a:p>
+            <a:pPr>
+              <a:defRPr sz="1400">
+                <a:solidFill>
+                  <a:srgbClr val="DCEBFA"/>
+                </a:solidFill>
+              </a:defRPr>
+            </a:pPr>
+            <a:r>
+              <a:t>Agentic, evidence-grounded triage for any Intel server-platform HSD</a:t>
+            </a:r>
+          </a:p>
+        </p:txBody>
+      </p:sp>
+      <p:sp>
+        <p:nvSpPr>
+          <p:cNvPr id="3" name="TextBox 2"/>
+          <p:cNvSpPr txBox="1"/>
+          <p:nvPr/>
+        </p:nvSpPr>
+        <p:spPr>
+          <a:xfrm>
+            <a:off x="548640" y="1280160"/>
+            <a:ext cx="11064240" cy="5120640"/>
+          </a:xfrm>
+          <a:prstGeom prst="rect">
+            <a:avLst/>
+          </a:prstGeom>
+          <a:noFill/>
+        </p:spPr>
+        <p:txBody>
+          <a:bodyPr wrap="square">
+            <a:spAutoFit/>
+          </a:bodyPr>
+          <a:lstStyle/>
+          <a:p>
+            <a:pPr>
+              <a:spcAft>
+                <a:spcPts val="600"/>
+              </a:spcAft>
+              <a:defRPr sz="1900">
+                <a:solidFill>
+                  <a:srgbClr val="1B1B2F"/>
+                </a:solidFill>
+              </a:defRPr>
+            </a:pPr>
+            <a:r>
+              <a:t>Give it an HSD ID — it reads the ticket + comments, decodes attached logs, recalls similar cases, and writes a structured Root-Cause-Analysis report.</a:t>
+            </a:r>
+          </a:p>
+          <a:p>
+            <a:pPr>
+              <a:spcAft>
+                <a:spcPts val="600"/>
+              </a:spcAft>
+              <a:defRPr sz="1900">
+                <a:solidFill>
+                  <a:srgbClr val="1B1B2F"/>
+                </a:solidFill>
+              </a:defRPr>
+            </a:pPr>
+            <a:r>
+              <a:t>Self-learning Knowledge Base: every ticket seen is written back, so matching improves over time.</a:t>
+            </a:r>
+          </a:p>
+          <a:p>
+            <a:pPr>
+              <a:spcAft>
+                <a:spcPts val="600"/>
+              </a:spcAft>
+              <a:defRPr sz="1900">
+                <a:solidFill>
+                  <a:srgbClr val="1B1B2F"/>
+                </a:solidFill>
+              </a:defRPr>
+            </a:pPr>
+            <a:r>
+              <a:t>Deterministic OFFLINE mode (no LLM required) using bundled Intel decoder databases.</a:t>
+            </a:r>
+          </a:p>
+          <a:p>
+            <a:pPr>
+              <a:spcAft>
+                <a:spcPts val="600"/>
+              </a:spcAft>
+              <a:defRPr sz="1900">
+                <a:solidFill>
+                  <a:srgbClr val="1B1B2F"/>
+                </a:solidFill>
+              </a:defRPr>
+            </a:pPr>
+            <a:r>
+              <a:t>Grounded in many sources at once: HSDES REST + Geni + Co-Design + Wiki KB + decoders + Axon.</a:t>
+            </a:r>
+          </a:p>
+          <a:p>
+            <a:pPr>
+              <a:spcAft>
+                <a:spcPts val="600"/>
+              </a:spcAft>
+              <a:defRPr sz="1900">
+                <a:solidFill>
+                  <a:srgbClr val="1B1B2F"/>
+                </a:solidFill>
+              </a:defRPr>
+            </a:pPr>
+            <a:r>
+              <a:t>NEW headline capability: PythonSV Live Debug through the bench NUC — reach a hung / unreachable SUT out-of-band.</a:t>
+            </a:r>
+          </a:p>
+          <a:p>
+            <a:pPr>
+              <a:spcAft>
+                <a:spcPts val="600"/>
+              </a:spcAft>
+              <a:defRPr sz="1900">
+                <a:solidFill>
+                  <a:srgbClr val="1B1B2F"/>
+                </a:solidFill>
+              </a:defRPr>
+            </a:pPr>
+            <a:r>
+              <a:t>Web UI (tabs) + unified CLI; reports saved as Markdown + HTML with a Reference Sources citation table.</a:t>
+            </a:r>
+          </a:p>
+        </p:txBody>
+      </p:sp>
+    </p:spTree>
+  </p:cSld>
+  <p:clrMapOvr>
+    <a:masterClrMapping/>
+  </p:clrMapOvr>
+</p:sld>
+</file>
+
+<file path=ppt/slides/slide17.xml><?xml version="1.0" encoding="utf-8"?>
+<p:sld xmlns:a="http://schemas.openxmlformats.org/drawingml/2006/main" xmlns:p="http://schemas.openxmlformats.org/presentationml/2006/main" xmlns:r="http://schemas.openxmlformats.org/officeDocument/2006/relationships">
+  <p:cSld>
+    <p:spTree>
+      <p:nvGrpSpPr>
+        <p:cNvPr id="1" name=""/>
+        <p:cNvGrpSpPr/>
+        <p:nvPr/>
+      </p:nvGrpSpPr>
+      <p:grpSpPr/>
+      <p:sp>
+        <p:nvSpPr>
+          <p:cNvPr id="2" name="Rectangle 1"/>
+          <p:cNvSpPr/>
+          <p:nvPr/>
+        </p:nvSpPr>
+        <p:spPr>
+          <a:xfrm>
+            <a:off x="0" y="0"/>
+            <a:ext cx="12192000" cy="960120"/>
+          </a:xfrm>
+          <a:prstGeom prst="rect">
+            <a:avLst/>
+          </a:prstGeom>
+          <a:solidFill>
+            <a:srgbClr val="0071C5"/>
+          </a:solidFill>
+          <a:ln>
+            <a:noFill/>
+          </a:ln>
+        </p:spPr>
+        <p:style>
+          <a:lnRef idx="1">
+            <a:schemeClr val="accent1"/>
+          </a:lnRef>
+          <a:fillRef idx="3">
+            <a:schemeClr val="accent1"/>
+          </a:fillRef>
+          <a:effectRef idx="2">
+            <a:schemeClr val="accent1"/>
+          </a:effectRef>
+          <a:fontRef idx="minor">
+            <a:schemeClr val="lt1"/>
+          </a:fontRef>
+        </p:style>
+        <p:txBody>
+          <a:bodyPr rtlCol="0" anchor="ctr" lIns="365760" wrap="square"/>
+          <a:lstStyle/>
+          <a:p>
+            <a:pPr algn="ctr">
+              <a:defRPr sz="3000" b="1">
+                <a:solidFill>
+                  <a:srgbClr val="FFFFFF"/>
+                </a:solidFill>
+              </a:defRPr>
+            </a:pPr>
+            <a:r>
+              <a:t>How it works — end-to-end flow</a:t>
+            </a:r>
+          </a:p>
+        </p:txBody>
+      </p:sp>
+      <p:sp>
+        <p:nvSpPr>
+          <p:cNvPr id="3" name="Rounded Rectangle 2"/>
+          <p:cNvSpPr/>
+          <p:nvPr/>
+        </p:nvSpPr>
+        <p:spPr>
+          <a:xfrm>
+            <a:off x="457200" y="1234440"/>
+            <a:ext cx="2057400" cy="566928"/>
+          </a:xfrm>
+          <a:prstGeom prst="roundRect">
+            <a:avLst/>
+          </a:prstGeom>
+          <a:solidFill>
+            <a:srgbClr val="0071C5"/>
+          </a:solidFill>
+          <a:ln>
+            <a:solidFill>
+              <a:srgbClr val="FFFFFF"/>
+            </a:solidFill>
+          </a:ln>
+        </p:spPr>
+        <p:style>
+          <a:lnRef idx="1">
+            <a:schemeClr val="accent1"/>
+          </a:lnRef>
+          <a:fillRef idx="3">
+            <a:schemeClr val="accent1"/>
+          </a:fillRef>
+          <a:effectRef idx="2">
+            <a:schemeClr val="accent1"/>
+          </a:effectRef>
+          <a:fontRef idx="minor">
+            <a:schemeClr val="lt1"/>
+          </a:fontRef>
+        </p:style>
+        <p:txBody>
+          <a:bodyPr rtlCol="0" anchor="ctr" wrap="square"/>
+          <a:lstStyle/>
+          <a:p>
+            <a:pPr algn="ctr">
+              <a:defRPr sz="1200" b="1">
+                <a:solidFill>
+                  <a:srgbClr val="FFFFFF"/>
+                </a:solidFill>
+              </a:defRPr>
+            </a:pPr>
+            <a:r>
+              <a:t>User · Web UI / CLI</a:t>
+            </a:r>
+          </a:p>
+        </p:txBody>
+      </p:sp>
+      <p:sp>
+        <p:nvSpPr>
+          <p:cNvPr id="4" name="Rounded Rectangle 3"/>
+          <p:cNvSpPr/>
+          <p:nvPr/>
+        </p:nvSpPr>
+        <p:spPr>
+          <a:xfrm>
+            <a:off x="2651760" y="1234440"/>
+            <a:ext cx="2057400" cy="566928"/>
+          </a:xfrm>
+          <a:prstGeom prst="roundRect">
+            <a:avLst/>
+          </a:prstGeom>
+          <a:solidFill>
+            <a:srgbClr val="2E7D32"/>
+          </a:solidFill>
+          <a:ln>
+            <a:solidFill>
+              <a:srgbClr val="FFFFFF"/>
+            </a:solidFill>
+          </a:ln>
+        </p:spPr>
+        <p:style>
+          <a:lnRef idx="1">
+            <a:schemeClr val="accent1"/>
+          </a:lnRef>
+          <a:fillRef idx="3">
+            <a:schemeClr val="accent1"/>
+          </a:fillRef>
+          <a:effectRef idx="2">
+            <a:schemeClr val="accent1"/>
+          </a:effectRef>
+          <a:fontRef idx="minor">
+            <a:schemeClr val="lt1"/>
+          </a:fontRef>
+        </p:style>
+        <p:txBody>
+          <a:bodyPr rtlCol="0" anchor="ctr" wrap="square"/>
+          <a:lstStyle/>
+          <a:p>
+            <a:pPr algn="ctr">
+              <a:defRPr sz="1200" b="1">
+                <a:solidFill>
+                  <a:srgbClr val="FFFFFF"/>
+                </a:solidFill>
+              </a:defRPr>
+            </a:pPr>
+            <a:r>
+              <a:t>RECALL · KB search</a:t>
+            </a:r>
+          </a:p>
+        </p:txBody>
+      </p:sp>
+      <p:cxnSp>
+        <p:nvCxnSpPr>
+          <p:cNvPr id="5" name="Connector 4"/>
+          <p:cNvCxnSpPr/>
+          <p:nvPr/>
+        </p:nvCxnSpPr>
+        <p:spPr>
+          <a:xfrm>
+            <a:off x="2514600" y="1517904"/>
+            <a:ext cx="137160" cy="0"/>
+          </a:xfrm>
+          <a:prstGeom prst="bentConnector3">
+            <a:avLst/>
+          </a:prstGeom>
+          <a:ln w="25400">
+            <a:solidFill>
+              <a:srgbClr val="5A6372"/>
+            </a:solidFill>
+          </a:ln>
+        </p:spPr>
+        <p:style>
+          <a:lnRef idx="2">
+            <a:schemeClr val="accent1"/>
+          </a:lnRef>
+          <a:fillRef idx="0">
+            <a:schemeClr val="accent1"/>
+          </a:fillRef>
+          <a:effectRef idx="1">
+            <a:schemeClr val="accent1"/>
+          </a:effectRef>
+          <a:fontRef idx="minor">
+            <a:schemeClr val="tx1"/>
+          </a:fontRef>
+        </p:style>
+      </p:cxnSp>
+      <p:sp>
+        <p:nvSpPr>
+          <p:cNvPr id="6" name="Rounded Rectangle 5"/>
+          <p:cNvSpPr/>
+          <p:nvPr/>
+        </p:nvSpPr>
+        <p:spPr>
+          <a:xfrm>
+            <a:off x="4846320" y="1234440"/>
+            <a:ext cx="2057400" cy="566928"/>
+          </a:xfrm>
+          <a:prstGeom prst="roundRect">
+            <a:avLst/>
+          </a:prstGeom>
+          <a:solidFill>
+            <a:srgbClr val="2E7D32"/>
+          </a:solidFill>
+          <a:ln>
+            <a:solidFill>
+              <a:srgbClr val="FFFFFF"/>
+            </a:solidFill>
+          </a:ln>
+        </p:spPr>
+        <p:style>
+          <a:lnRef idx="1">
+            <a:schemeClr val="accent1"/>
+          </a:lnRef>
+          <a:fillRef idx="3">
+            <a:schemeClr val="accent1"/>
+          </a:fillRef>
+          <a:effectRef idx="2">
+            <a:schemeClr val="accent1"/>
+          </a:effectRef>
+          <a:fontRef idx="minor">
+            <a:schemeClr val="lt1"/>
+          </a:fontRef>
+        </p:style>
+        <p:txBody>
+          <a:bodyPr rtlCol="0" anchor="ctr" wrap="square"/>
+          <a:lstStyle/>
+          <a:p>
+            <a:pPr algn="ctr">
+              <a:defRPr sz="1200" b="1">
+                <a:solidFill>
+                  <a:srgbClr val="FFFFFF"/>
+                </a:solidFill>
+              </a:defRPr>
+            </a:pPr>
+            <a:r>
+              <a:t>INVESTIGATE · HSD + comments + logs</a:t>
+            </a:r>
+          </a:p>
+        </p:txBody>
+      </p:sp>
+      <p:cxnSp>
+        <p:nvCxnSpPr>
+          <p:cNvPr id="7" name="Connector 6"/>
+          <p:cNvCxnSpPr/>
+          <p:nvPr/>
+        </p:nvCxnSpPr>
+        <p:spPr>
+          <a:xfrm>
+            <a:off x="4709160" y="1517904"/>
+            <a:ext cx="137160" cy="0"/>
+          </a:xfrm>
+          <a:prstGeom prst="bentConnector3">
+            <a:avLst/>
+          </a:prstGeom>
+          <a:ln w="25400">
+            <a:solidFill>
+              <a:srgbClr val="5A6372"/>
+            </a:solidFill>
+          </a:ln>
+        </p:spPr>
+        <p:style>
+          <a:lnRef idx="2">
+            <a:schemeClr val="accent1"/>
+          </a:lnRef>
+          <a:fillRef idx="0">
+            <a:schemeClr val="accent1"/>
+          </a:fillRef>
+          <a:effectRef idx="1">
+            <a:schemeClr val="accent1"/>
+          </a:effectRef>
+          <a:fontRef idx="minor">
+            <a:schemeClr val="tx1"/>
+          </a:fontRef>
+        </p:style>
+      </p:cxnSp>
+      <p:sp>
+        <p:nvSpPr>
+          <p:cNvPr id="8" name="Rounded Rectangle 7"/>
+          <p:cNvSpPr/>
+          <p:nvPr/>
+        </p:nvSpPr>
+        <p:spPr>
+          <a:xfrm>
+            <a:off x="7040880" y="1234440"/>
+            <a:ext cx="2057400" cy="566928"/>
+          </a:xfrm>
+          <a:prstGeom prst="roundRect">
+            <a:avLst/>
+          </a:prstGeom>
+          <a:solidFill>
+            <a:srgbClr val="B07400"/>
+          </a:solidFill>
+          <a:ln>
+            <a:solidFill>
+              <a:srgbClr val="FFFFFF"/>
+            </a:solidFill>
+          </a:ln>
+        </p:spPr>
+        <p:style>
+          <a:lnRef idx="1">
+            <a:schemeClr val="accent1"/>
+          </a:lnRef>
+          <a:fillRef idx="3">
+            <a:schemeClr val="accent1"/>
+          </a:fillRef>
+          <a:effectRef idx="2">
+            <a:schemeClr val="accent1"/>
+          </a:effectRef>
+          <a:fontRef idx="minor">
+            <a:schemeClr val="lt1"/>
+          </a:fontRef>
+        </p:style>
+        <p:txBody>
+          <a:bodyPr rtlCol="0" anchor="ctr" wrap="square"/>
+          <a:lstStyle/>
+          <a:p>
+            <a:pPr algn="ctr">
+              <a:defRPr sz="1200" b="1">
+                <a:solidFill>
+                  <a:srgbClr val="FFFFFF"/>
+                </a:solidFill>
+              </a:defRPr>
+            </a:pPr>
+            <a:r>
+              <a:t>DECODE · MCA/EWL/POST + Enrichment</a:t>
+            </a:r>
+          </a:p>
+        </p:txBody>
+      </p:sp>
+      <p:cxnSp>
+        <p:nvCxnSpPr>
+          <p:cNvPr id="9" name="Connector 8"/>
+          <p:cNvCxnSpPr/>
+          <p:nvPr/>
+        </p:nvCxnSpPr>
+        <p:spPr>
+          <a:xfrm>
+            <a:off x="6903720" y="1517904"/>
+            <a:ext cx="137160" cy="0"/>
+          </a:xfrm>
+          <a:prstGeom prst="bentConnector3">
+            <a:avLst/>
+          </a:prstGeom>
+          <a:ln w="25400">
+            <a:solidFill>
+              <a:srgbClr val="5A6372"/>
+            </a:solidFill>
+          </a:ln>
+        </p:spPr>
+        <p:style>
+          <a:lnRef idx="2">
+            <a:schemeClr val="accent1"/>
+          </a:lnRef>
+          <a:fillRef idx="0">
+            <a:schemeClr val="accent1"/>
+          </a:fillRef>
+          <a:effectRef idx="1">
+            <a:schemeClr val="accent1"/>
+          </a:effectRef>
+          <a:fontRef idx="minor">
+            <a:schemeClr val="tx1"/>
+          </a:fontRef>
+        </p:style>
+      </p:cxnSp>
+      <p:sp>
+        <p:nvSpPr>
+          <p:cNvPr id="10" name="Rounded Rectangle 9"/>
+          <p:cNvSpPr/>
+          <p:nvPr/>
+        </p:nvSpPr>
+        <p:spPr>
+          <a:xfrm>
+            <a:off x="9235440" y="1234440"/>
+            <a:ext cx="2057400" cy="566928"/>
+          </a:xfrm>
+          <a:prstGeom prst="roundRect">
+            <a:avLst/>
+          </a:prstGeom>
+          <a:solidFill>
+            <a:srgbClr val="0071C5"/>
+          </a:solidFill>
+          <a:ln>
+            <a:solidFill>
+              <a:srgbClr val="FFFFFF"/>
+            </a:solidFill>
+          </a:ln>
+        </p:spPr>
+        <p:style>
+          <a:lnRef idx="1">
+            <a:schemeClr val="accent1"/>
+          </a:lnRef>
+          <a:fillRef idx="3">
+            <a:schemeClr val="accent1"/>
+          </a:fillRef>
+          <a:effectRef idx="2">
+            <a:schemeClr val="accent1"/>
+          </a:effectRef>
+          <a:fontRef idx="minor">
+            <a:schemeClr val="lt1"/>
+          </a:fontRef>
+        </p:style>
+        <p:txBody>
+          <a:bodyPr rtlCol="0" anchor="ctr" wrap="square"/>
+          <a:lstStyle/>
+          <a:p>
+            <a:pPr algn="ctr">
+              <a:defRPr sz="1200" b="1">
+                <a:solidFill>
+                  <a:srgbClr val="FFFFFF"/>
+                </a:solidFill>
+              </a:defRPr>
+            </a:pPr>
+            <a:r>
+              <a:t>REPORT · RCA + Reference Sources</a:t>
+            </a:r>
+          </a:p>
+        </p:txBody>
+      </p:sp>
+      <p:cxnSp>
+        <p:nvCxnSpPr>
+          <p:cNvPr id="11" name="Connector 10"/>
+          <p:cNvCxnSpPr/>
+          <p:nvPr/>
+        </p:nvCxnSpPr>
+        <p:spPr>
+          <a:xfrm>
+            <a:off x="9098280" y="1517904"/>
+            <a:ext cx="137160" cy="0"/>
+          </a:xfrm>
+          <a:prstGeom prst="bentConnector3">
+            <a:avLst/>
+          </a:prstGeom>
+          <a:ln w="25400">
+            <a:solidFill>
+              <a:srgbClr val="5A6372"/>
+            </a:solidFill>
+          </a:ln>
+        </p:spPr>
+        <p:style>
+          <a:lnRef idx="2">
+            <a:schemeClr val="accent1"/>
+          </a:lnRef>
+          <a:fillRef idx="0">
+            <a:schemeClr val="accent1"/>
+          </a:fillRef>
+          <a:effectRef idx="1">
+            <a:schemeClr val="accent1"/>
+          </a:effectRef>
+          <a:fontRef idx="minor">
+            <a:schemeClr val="tx1"/>
+          </a:fontRef>
+        </p:style>
+      </p:cxnSp>
+      <p:sp>
+        <p:nvSpPr>
+          <p:cNvPr id="12" name="Rounded Rectangle 11"/>
+          <p:cNvSpPr/>
+          <p:nvPr/>
+        </p:nvSpPr>
+        <p:spPr>
+          <a:xfrm>
+            <a:off x="457200" y="2286000"/>
+            <a:ext cx="2743200" cy="502920"/>
+          </a:xfrm>
+          <a:prstGeom prst="roundRect">
+            <a:avLst/>
+          </a:prstGeom>
+          <a:solidFill>
+            <a:srgbClr val="5A6372"/>
+          </a:solidFill>
+          <a:ln>
+            <a:solidFill>
+              <a:srgbClr val="FFFFFF"/>
+            </a:solidFill>
+          </a:ln>
+        </p:spPr>
+        <p:style>
+          <a:lnRef idx="1">
+            <a:schemeClr val="accent1"/>
+          </a:lnRef>
+          <a:fillRef idx="3">
+            <a:schemeClr val="accent1"/>
+          </a:fillRef>
+          <a:effectRef idx="2">
+            <a:schemeClr val="accent1"/>
+          </a:effectRef>
+          <a:fontRef idx="minor">
+            <a:schemeClr val="lt1"/>
+          </a:fontRef>
+        </p:style>
+        <p:txBody>
+          <a:bodyPr rtlCol="0" anchor="ctr" wrap="square"/>
+          <a:lstStyle/>
+          <a:p>
+            <a:pPr algn="ctr">
+              <a:defRPr sz="1100" b="1">
+                <a:solidFill>
+                  <a:srgbClr val="FFFFFF"/>
+                </a:solidFill>
+              </a:defRPr>
+            </a:pPr>
+            <a:r>
+              <a:t>Decoders: MCA / EWL / RC-Fatal / MCHECK / POST</a:t>
+            </a:r>
+          </a:p>
+        </p:txBody>
+      </p:sp>
+      <p:sp>
+        <p:nvSpPr>
+          <p:cNvPr id="13" name="Rounded Rectangle 12"/>
+          <p:cNvSpPr/>
+          <p:nvPr/>
+        </p:nvSpPr>
+        <p:spPr>
+          <a:xfrm>
+            <a:off x="3383280" y="2286000"/>
+            <a:ext cx="2743200" cy="502920"/>
+          </a:xfrm>
+          <a:prstGeom prst="roundRect">
+            <a:avLst/>
+          </a:prstGeom>
+          <a:solidFill>
+            <a:srgbClr val="5A6372"/>
+          </a:solidFill>
+          <a:ln>
+            <a:solidFill>
+              <a:srgbClr val="FFFFFF"/>
+            </a:solidFill>
+          </a:ln>
+        </p:spPr>
+        <p:style>
+          <a:lnRef idx="1">
+            <a:schemeClr val="accent1"/>
+          </a:lnRef>
+          <a:fillRef idx="3">
+            <a:schemeClr val="accent1"/>
+          </a:fillRef>
+          <a:effectRef idx="2">
+            <a:schemeClr val="accent1"/>
+          </a:effectRef>
+          <a:fontRef idx="minor">
+            <a:schemeClr val="lt1"/>
+          </a:fontRef>
+        </p:style>
+        <p:txBody>
+          <a:bodyPr rtlCol="0" anchor="ctr" wrap="square"/>
+          <a:lstStyle/>
+          <a:p>
+            <a:pPr algn="ctr">
+              <a:defRPr sz="1100" b="1">
+                <a:solidFill>
+                  <a:srgbClr val="FFFFFF"/>
+                </a:solidFill>
+              </a:defRPr>
+            </a:pPr>
+            <a:r>
+              <a:t>Wiki KB · Geni · Co-Design (always)</a:t>
+            </a:r>
+          </a:p>
+        </p:txBody>
+      </p:sp>
+      <p:sp>
+        <p:nvSpPr>
+          <p:cNvPr id="14" name="Rounded Rectangle 13"/>
+          <p:cNvSpPr/>
+          <p:nvPr/>
+        </p:nvSpPr>
+        <p:spPr>
+          <a:xfrm>
+            <a:off x="6309360" y="2286000"/>
+            <a:ext cx="2743200" cy="502920"/>
+          </a:xfrm>
+          <a:prstGeom prst="roundRect">
+            <a:avLst/>
+          </a:prstGeom>
+          <a:solidFill>
+            <a:srgbClr val="5A6372"/>
+          </a:solidFill>
+          <a:ln>
+            <a:solidFill>
+              <a:srgbClr val="FFFFFF"/>
+            </a:solidFill>
+          </a:ln>
+        </p:spPr>
+        <p:style>
+          <a:lnRef idx="1">
+            <a:schemeClr val="accent1"/>
+          </a:lnRef>
+          <a:fillRef idx="3">
+            <a:schemeClr val="accent1"/>
+          </a:fillRef>
+          <a:effectRef idx="2">
+            <a:schemeClr val="accent1"/>
+          </a:effectRef>
+          <a:fontRef idx="minor">
+            <a:schemeClr val="lt1"/>
+          </a:fontRef>
+        </p:style>
+        <p:txBody>
+          <a:bodyPr rtlCol="0" anchor="ctr" wrap="square"/>
+          <a:lstStyle/>
+          <a:p>
+            <a:pPr algn="ctr">
+              <a:defRPr sz="1100" b="1">
+                <a:solidFill>
+                  <a:srgbClr val="FFFFFF"/>
+                </a:solidFill>
+              </a:defRPr>
+            </a:pPr>
+            <a:r>
+              <a:t>BIOS/S3M · Kernel-crash · Redfish (need-based)</a:t>
+            </a:r>
+          </a:p>
+        </p:txBody>
+      </p:sp>
+      <p:sp>
+        <p:nvSpPr>
+          <p:cNvPr id="15" name="Rounded Rectangle 14"/>
+          <p:cNvSpPr/>
+          <p:nvPr/>
+        </p:nvSpPr>
+        <p:spPr>
+          <a:xfrm>
+            <a:off x="9235440" y="2286000"/>
+            <a:ext cx="2377440" cy="502920"/>
+          </a:xfrm>
+          <a:prstGeom prst="roundRect">
+            <a:avLst/>
+          </a:prstGeom>
+          <a:solidFill>
+            <a:srgbClr val="5A6372"/>
+          </a:solidFill>
+          <a:ln>
+            <a:solidFill>
+              <a:srgbClr val="FFFFFF"/>
+            </a:solidFill>
+          </a:ln>
+        </p:spPr>
+        <p:style>
+          <a:lnRef idx="1">
+            <a:schemeClr val="accent1"/>
+          </a:lnRef>
+          <a:fillRef idx="3">
+            <a:schemeClr val="accent1"/>
+          </a:fillRef>
+          <a:effectRef idx="2">
+            <a:schemeClr val="accent1"/>
+          </a:effectRef>
+          <a:fontRef idx="minor">
+            <a:schemeClr val="lt1"/>
+          </a:fontRef>
+        </p:style>
+        <p:txBody>
+          <a:bodyPr rtlCol="0" anchor="ctr" wrap="square"/>
+          <a:lstStyle/>
+          <a:p>
+            <a:pPr algn="ctr">
+              <a:defRPr sz="1100" b="1">
+                <a:solidFill>
+                  <a:srgbClr val="FFFFFF"/>
+                </a:solidFill>
+              </a:defRPr>
+            </a:pPr>
+            <a:r>
+              <a:t>Axon SVTools recordings</a:t>
+            </a:r>
+          </a:p>
+        </p:txBody>
+      </p:sp>
+      <p:sp>
+        <p:nvSpPr>
+          <p:cNvPr id="16" name="TextBox 15"/>
+          <p:cNvSpPr txBox="1"/>
+          <p:nvPr/>
+        </p:nvSpPr>
+        <p:spPr>
+          <a:xfrm>
+            <a:off x="457200" y="3246120"/>
+            <a:ext cx="11247120" cy="365760"/>
+          </a:xfrm>
+          <a:prstGeom prst="rect">
+            <a:avLst/>
+          </a:prstGeom>
+          <a:noFill/>
+        </p:spPr>
+        <p:txBody>
+          <a:bodyPr wrap="square">
+            <a:spAutoFit/>
+          </a:bodyPr>
+          <a:lstStyle/>
+          <a:p>
+            <a:pPr>
+              <a:defRPr sz="1500" b="1">
+                <a:solidFill>
+                  <a:srgbClr val="1B1B2F"/>
+                </a:solidFill>
+              </a:defRPr>
+            </a:pPr>
+            <a:r>
+              <a:t>PythonSV Live-Debug path (SUT hung / unreachable):</a:t>
+            </a:r>
+          </a:p>
+        </p:txBody>
+      </p:sp>
+      <p:sp>
+        <p:nvSpPr>
+          <p:cNvPr id="17" name="Rounded Rectangle 16"/>
+          <p:cNvSpPr/>
+          <p:nvPr/>
+        </p:nvSpPr>
+        <p:spPr>
+          <a:xfrm>
+            <a:off x="457200" y="3703320"/>
+            <a:ext cx="2651760" cy="640080"/>
+          </a:xfrm>
+          <a:prstGeom prst="roundRect">
+            <a:avLst/>
+          </a:prstGeom>
+          <a:solidFill>
+            <a:srgbClr val="0071C5"/>
+          </a:solidFill>
+          <a:ln>
+            <a:solidFill>
+              <a:srgbClr val="FFFFFF"/>
+            </a:solidFill>
+          </a:ln>
+        </p:spPr>
+        <p:style>
+          <a:lnRef idx="1">
+            <a:schemeClr val="accent1"/>
+          </a:lnRef>
+          <a:fillRef idx="3">
+            <a:schemeClr val="accent1"/>
+          </a:fillRef>
+          <a:effectRef idx="2">
+            <a:schemeClr val="accent1"/>
+          </a:effectRef>
+          <a:fontRef idx="minor">
+            <a:schemeClr val="lt1"/>
+          </a:fontRef>
+        </p:style>
+        <p:txBody>
+          <a:bodyPr rtlCol="0" anchor="ctr" wrap="square"/>
+          <a:lstStyle/>
+          <a:p>
+            <a:pPr algn="ctr">
+              <a:defRPr sz="1200" b="1">
+                <a:solidFill>
+                  <a:srgbClr val="FFFFFF"/>
+                </a:solidFill>
+              </a:defRPr>
+            </a:pPr>
+            <a:r>
+              <a:t>NEXUS server</a:t>
+            </a:r>
+          </a:p>
+        </p:txBody>
+      </p:sp>
+      <p:sp>
+        <p:nvSpPr>
+          <p:cNvPr id="18" name="Rounded Rectangle 17"/>
+          <p:cNvSpPr/>
+          <p:nvPr/>
+        </p:nvSpPr>
+        <p:spPr>
+          <a:xfrm>
+            <a:off x="3246120" y="3703320"/>
+            <a:ext cx="2651760" cy="640080"/>
+          </a:xfrm>
+          <a:prstGeom prst="roundRect">
+            <a:avLst/>
+          </a:prstGeom>
+          <a:solidFill>
+            <a:srgbClr val="B07400"/>
+          </a:solidFill>
+          <a:ln>
+            <a:solidFill>
+              <a:srgbClr val="FFFFFF"/>
+            </a:solidFill>
+          </a:ln>
+        </p:spPr>
+        <p:style>
+          <a:lnRef idx="1">
+            <a:schemeClr val="accent1"/>
+          </a:lnRef>
+          <a:fillRef idx="3">
+            <a:schemeClr val="accent1"/>
+          </a:fillRef>
+          <a:effectRef idx="2">
+            <a:schemeClr val="accent1"/>
+          </a:effectRef>
+          <a:fontRef idx="minor">
+            <a:schemeClr val="lt1"/>
+          </a:fontRef>
+        </p:style>
+        <p:txBody>
+          <a:bodyPr rtlCol="0" anchor="ctr" wrap="square"/>
+          <a:lstStyle/>
+          <a:p>
+            <a:pPr algn="ctr">
+              <a:defRPr sz="1200" b="1">
+                <a:solidFill>
+                  <a:srgbClr val="FFFFFF"/>
+                </a:solidFill>
+              </a:defRPr>
+            </a:pPr>
+            <a:r>
+              <a:t>SSH :22  (WinRM :5985 fallback)</a:t>
+            </a:r>
+          </a:p>
+        </p:txBody>
+      </p:sp>
+      <p:cxnSp>
+        <p:nvCxnSpPr>
+          <p:cNvPr id="19" name="Connector 18"/>
+          <p:cNvCxnSpPr/>
+          <p:nvPr/>
+        </p:nvCxnSpPr>
+        <p:spPr>
+          <a:xfrm>
+            <a:off x="3108960" y="4023360"/>
+            <a:ext cx="137160" cy="0"/>
+          </a:xfrm>
+          <a:prstGeom prst="bentConnector3">
+            <a:avLst/>
+          </a:prstGeom>
+          <a:ln w="25400">
+            <a:solidFill>
+              <a:srgbClr val="5A6372"/>
+            </a:solidFill>
+          </a:ln>
+        </p:spPr>
+        <p:style>
+          <a:lnRef idx="2">
+            <a:schemeClr val="accent1"/>
+          </a:lnRef>
+          <a:fillRef idx="0">
+            <a:schemeClr val="accent1"/>
+          </a:fillRef>
+          <a:effectRef idx="1">
+            <a:schemeClr val="accent1"/>
+          </a:effectRef>
+          <a:fontRef idx="minor">
+            <a:schemeClr val="tx1"/>
+          </a:fontRef>
+        </p:style>
+      </p:cxnSp>
+      <p:sp>
+        <p:nvSpPr>
+          <p:cNvPr id="20" name="Rounded Rectangle 19"/>
+          <p:cNvSpPr/>
+          <p:nvPr/>
+        </p:nvSpPr>
+        <p:spPr>
+          <a:xfrm>
+            <a:off x="6035040" y="3703320"/>
+            <a:ext cx="2651760" cy="640080"/>
+          </a:xfrm>
+          <a:prstGeom prst="roundRect">
+            <a:avLst/>
+          </a:prstGeom>
+          <a:solidFill>
+            <a:srgbClr val="2E7D32"/>
+          </a:solidFill>
+          <a:ln>
+            <a:solidFill>
+              <a:srgbClr val="FFFFFF"/>
+            </a:solidFill>
+          </a:ln>
+        </p:spPr>
+        <p:style>
+          <a:lnRef idx="1">
+            <a:schemeClr val="accent1"/>
+          </a:lnRef>
+          <a:fillRef idx="3">
+            <a:schemeClr val="accent1"/>
+          </a:fillRef>
+          <a:effectRef idx="2">
+            <a:schemeClr val="accent1"/>
+          </a:effectRef>
+          <a:fontRef idx="minor">
+            <a:schemeClr val="lt1"/>
+          </a:fontRef>
+        </p:style>
+        <p:txBody>
+          <a:bodyPr rtlCol="0" anchor="ctr" wrap="square"/>
+          <a:lstStyle/>
+          <a:p>
+            <a:pPr algn="ctr">
+              <a:defRPr sz="1200" b="1">
+                <a:solidFill>
+                  <a:srgbClr val="FFFFFF"/>
+                </a:solidFill>
+              </a:defRPr>
+            </a:pPr>
+            <a:r>
+              <a:t>Lab NUC · Windows + PythonSV</a:t>
+            </a:r>
+          </a:p>
+        </p:txBody>
+      </p:sp>
+      <p:cxnSp>
+        <p:nvCxnSpPr>
+          <p:cNvPr id="21" name="Connector 20"/>
+          <p:cNvCxnSpPr/>
+          <p:nvPr/>
+        </p:nvCxnSpPr>
+        <p:spPr>
+          <a:xfrm>
+            <a:off x="5897880" y="4023360"/>
+            <a:ext cx="137160" cy="0"/>
+          </a:xfrm>
+          <a:prstGeom prst="bentConnector3">
+            <a:avLst/>
+          </a:prstGeom>
+          <a:ln w="25400">
+            <a:solidFill>
+              <a:srgbClr val="5A6372"/>
+            </a:solidFill>
+          </a:ln>
+        </p:spPr>
+        <p:style>
+          <a:lnRef idx="2">
+            <a:schemeClr val="accent1"/>
+          </a:lnRef>
+          <a:fillRef idx="0">
+            <a:schemeClr val="accent1"/>
+          </a:fillRef>
+          <a:effectRef idx="1">
+            <a:schemeClr val="accent1"/>
+          </a:effectRef>
+          <a:fontRef idx="minor">
+            <a:schemeClr val="tx1"/>
+          </a:fontRef>
+        </p:style>
+      </p:cxnSp>
+      <p:sp>
+        <p:nvSpPr>
+          <p:cNvPr id="22" name="Rounded Rectangle 21"/>
+          <p:cNvSpPr/>
+          <p:nvPr/>
+        </p:nvSpPr>
+        <p:spPr>
+          <a:xfrm>
+            <a:off x="8823960" y="3703320"/>
+            <a:ext cx="2651760" cy="640080"/>
+          </a:xfrm>
+          <a:prstGeom prst="roundRect">
+            <a:avLst/>
+          </a:prstGeom>
+          <a:solidFill>
+            <a:srgbClr val="1B1B2F"/>
+          </a:solidFill>
+          <a:ln>
+            <a:solidFill>
+              <a:srgbClr val="FFFFFF"/>
+            </a:solidFill>
+          </a:ln>
+        </p:spPr>
+        <p:style>
+          <a:lnRef idx="1">
+            <a:schemeClr val="accent1"/>
+          </a:lnRef>
+          <a:fillRef idx="3">
+            <a:schemeClr val="accent1"/>
+          </a:fillRef>
+          <a:effectRef idx="2">
+            <a:schemeClr val="accent1"/>
+          </a:effectRef>
+          <a:fontRef idx="minor">
+            <a:schemeClr val="lt1"/>
+          </a:fontRef>
+        </p:style>
+        <p:txBody>
+          <a:bodyPr rtlCol="0" anchor="ctr" wrap="square"/>
+          <a:lstStyle/>
+          <a:p>
+            <a:pPr algn="ctr">
+              <a:defRPr sz="1200" b="1">
+                <a:solidFill>
+                  <a:srgbClr val="FFFFFF"/>
+                </a:solidFill>
+              </a:defRPr>
+            </a:pPr>
+            <a:r>
+              <a:t>ITP / sideband -&gt; hung SUT</a:t>
+            </a:r>
+          </a:p>
+        </p:txBody>
+      </p:sp>
+      <p:cxnSp>
+        <p:nvCxnSpPr>
+          <p:cNvPr id="23" name="Connector 22"/>
+          <p:cNvCxnSpPr/>
+          <p:nvPr/>
+        </p:nvCxnSpPr>
+        <p:spPr>
+          <a:xfrm>
+            <a:off x="8686800" y="4023360"/>
+            <a:ext cx="137160" cy="0"/>
+          </a:xfrm>
+          <a:prstGeom prst="bentConnector3">
+            <a:avLst/>
+          </a:prstGeom>
+          <a:ln w="25400">
+            <a:solidFill>
+              <a:srgbClr val="5A6372"/>
+            </a:solidFill>
+          </a:ln>
+        </p:spPr>
+        <p:style>
+          <a:lnRef idx="2">
+            <a:schemeClr val="accent1"/>
+          </a:lnRef>
+          <a:fillRef idx="0">
+            <a:schemeClr val="accent1"/>
+          </a:fillRef>
+          <a:effectRef idx="1">
+            <a:schemeClr val="accent1"/>
+          </a:effectRef>
+          <a:fontRef idx="minor">
+            <a:schemeClr val="tx1"/>
+          </a:fontRef>
+        </p:style>
+      </p:cxnSp>
+      <p:sp>
+        <p:nvSpPr>
+          <p:cNvPr id="24" name="TextBox 23"/>
+          <p:cNvSpPr txBox="1"/>
+          <p:nvPr/>
+        </p:nvSpPr>
+        <p:spPr>
+          <a:xfrm>
+            <a:off x="457200" y="4617720"/>
+            <a:ext cx="11247120" cy="1920240"/>
+          </a:xfrm>
+          <a:prstGeom prst="rect">
+            <a:avLst/>
+          </a:prstGeom>
+          <a:noFill/>
+        </p:spPr>
+        <p:txBody>
+          <a:bodyPr wrap="square">
+            <a:spAutoFit/>
+          </a:bodyPr>
+          <a:lstStyle/>
+          <a:p>
+            <a:pPr>
+              <a:spcAft>
+                <a:spcPts val="600"/>
+              </a:spcAft>
+              <a:defRPr sz="1500">
+                <a:solidFill>
+                  <a:srgbClr val="1B1B2F"/>
+                </a:solidFill>
+              </a:defRPr>
+            </a:pPr>
+            <a:r>
+              <a:t>One persistent PythonSV session — imports &amp; IPC state persist across lines.</a:t>
+            </a:r>
+          </a:p>
+          <a:p>
+            <a:pPr>
+              <a:spcAft>
+                <a:spcPts val="600"/>
+              </a:spcAft>
+              <a:defRPr sz="1500">
+                <a:solidFill>
+                  <a:srgbClr val="1B1B2F"/>
+                </a:solidFill>
+              </a:defRPr>
+            </a:pPr>
+            <a:r>
+              <a:t>Auto-init preamble (ipc.unlock() + sv.refresh()) runs first; output cleaned; state auto-interpreted into plain-English notes.</a:t>
+            </a:r>
+          </a:p>
+          <a:p>
+            <a:pPr>
+              <a:spcAft>
+                <a:spcPts val="600"/>
+              </a:spcAft>
+              <a:defRPr sz="1500">
+                <a:solidFill>
+                  <a:srgbClr val="1B1B2F"/>
+                </a:solidFill>
+              </a:defRPr>
+            </a:pPr>
+            <a:r>
+              <a:t>Password entered in UI only — masked, never stored or logged.</a:t>
+            </a:r>
+          </a:p>
+        </p:txBody>
+      </p:sp>
+    </p:spTree>
+  </p:cSld>
+  <p:clrMapOvr>
+    <a:masterClrMapping/>
+  </p:clrMapOvr>
+</p:sld>
+</file>
+
+<file path=ppt/slides/slide18.xml><?xml version="1.0" encoding="utf-8"?>
+<p:sld xmlns:a="http://schemas.openxmlformats.org/drawingml/2006/main" xmlns:p="http://schemas.openxmlformats.org/presentationml/2006/main" xmlns:r="http://schemas.openxmlformats.org/officeDocument/2006/relationships">
+  <p:cSld>
+    <p:spTree>
+      <p:nvGrpSpPr>
+        <p:cNvPr id="1" name=""/>
+        <p:cNvGrpSpPr/>
+        <p:nvPr/>
+      </p:nvGrpSpPr>
+      <p:grpSpPr/>
+      <p:sp>
+        <p:nvSpPr>
+          <p:cNvPr id="2" name="Rectangle 1"/>
+          <p:cNvSpPr/>
+          <p:nvPr/>
+        </p:nvSpPr>
+        <p:spPr>
+          <a:xfrm>
+            <a:off x="0" y="0"/>
+            <a:ext cx="12192000" cy="960120"/>
+          </a:xfrm>
+          <a:prstGeom prst="rect">
+            <a:avLst/>
+          </a:prstGeom>
+          <a:solidFill>
+            <a:srgbClr val="0071C5"/>
+          </a:solidFill>
+          <a:ln>
+            <a:noFill/>
+          </a:ln>
+        </p:spPr>
+        <p:style>
+          <a:lnRef idx="1">
+            <a:schemeClr val="accent1"/>
+          </a:lnRef>
+          <a:fillRef idx="3">
+            <a:schemeClr val="accent1"/>
+          </a:fillRef>
+          <a:effectRef idx="2">
+            <a:schemeClr val="accent1"/>
+          </a:effectRef>
+          <a:fontRef idx="minor">
+            <a:schemeClr val="lt1"/>
+          </a:fontRef>
+        </p:style>
+        <p:txBody>
+          <a:bodyPr rtlCol="0" anchor="ctr" lIns="365760" wrap="square"/>
+          <a:lstStyle/>
+          <a:p>
+            <a:pPr algn="ctr">
+              <a:defRPr sz="3000" b="1">
+                <a:solidFill>
+                  <a:srgbClr val="FFFFFF"/>
+                </a:solidFill>
+              </a:defRPr>
+            </a:pPr>
+            <a:r>
+              <a:t>New in HSDES NEXUS vs. original BugScout</a:t>
+            </a:r>
+          </a:p>
+        </p:txBody>
+      </p:sp>
+      <p:graphicFrame>
+        <p:nvGraphicFramePr>
+          <p:cNvPr id="3" name="Table 2"/>
+          <p:cNvGraphicFramePr>
+            <a:graphicFrameLocks noGrp="1"/>
+          </p:cNvGraphicFramePr>
+          <p:nvPr/>
+        </p:nvGraphicFramePr>
+        <p:xfrm>
+          <a:off x="365760" y="1143000"/>
+          <a:ext cx="11430000" cy="5394960"/>
+        </p:xfrm>
+        <a:graphic>
+          <a:graphicData uri="http://schemas.openxmlformats.org/drawingml/2006/table">
+            <a:tbl>
+              <a:tblPr firstRow="1" bandRow="1">
+                <a:tableStyleId>{5C22544A-7EE6-4342-B048-85BDC9FD1C3A}</a:tableStyleId>
+              </a:tblPr>
+              <a:tblGrid>
+                <a:gridCol w="1920240"/>
+                <a:gridCol w="3383280"/>
+                <a:gridCol w="6126480"/>
+              </a:tblGrid>
+              <a:tr h="449580">
+                <a:tc>
+                  <a:txBody>
+                    <a:bodyPr/>
+                    <a:lstStyle/>
+                    <a:p>
+                      <a:pPr>
+                        <a:defRPr sz="1300" b="1">
+                          <a:solidFill>
+                            <a:srgbClr val="FFFFFF"/>
+                          </a:solidFill>
+                        </a:defRPr>
+                      </a:pPr>
+                      <a:r>
+                        <a:t>Area</a:t>
+                      </a:r>
+                    </a:p>
+                  </a:txBody>
+                  <a:tcPr>
+                    <a:solidFill>
+                      <a:srgbClr val="0071C5"/>
+                    </a:solidFill>
+                  </a:tcPr>
+                </a:tc>
+                <a:tc>
+                  <a:txBody>
+                    <a:bodyPr/>
+                    <a:lstStyle/>
+                    <a:p>
+                      <a:pPr>
+                        <a:defRPr sz="1300" b="1">
+                          <a:solidFill>
+                            <a:srgbClr val="FFFFFF"/>
+                          </a:solidFill>
+                        </a:defRPr>
+                      </a:pPr>
+                      <a:r>
+                        <a:t>Original BugScout</a:t>
+                      </a:r>
+                    </a:p>
+                  </a:txBody>
+                  <a:tcPr>
+                    <a:solidFill>
+                      <a:srgbClr val="0071C5"/>
+                    </a:solidFill>
+                  </a:tcPr>
+                </a:tc>
+                <a:tc>
+                  <a:txBody>
+                    <a:bodyPr/>
+                    <a:lstStyle/>
+                    <a:p>
+                      <a:pPr>
+                        <a:defRPr sz="1300" b="1">
+                          <a:solidFill>
+                            <a:srgbClr val="FFFFFF"/>
+                          </a:solidFill>
+                        </a:defRPr>
+                      </a:pPr>
+                      <a:r>
+                        <a:t>New in HSDES NEXUS</a:t>
+                      </a:r>
+                    </a:p>
+                  </a:txBody>
+                  <a:tcPr>
+                    <a:solidFill>
+                      <a:srgbClr val="0071C5"/>
+                    </a:solidFill>
+                  </a:tcPr>
+                </a:tc>
+              </a:tr>
+              <a:tr h="449580">
+                <a:tc>
+                  <a:txBody>
+                    <a:bodyPr/>
+                    <a:lstStyle/>
+                    <a:p>
+                      <a:pPr>
+                        <a:defRPr sz="1200" b="0">
+                          <a:solidFill>
+                            <a:srgbClr val="1B1B2F"/>
+                          </a:solidFill>
+                        </a:defRPr>
+                      </a:pPr>
+                      <a:r>
+                        <a:t>Packaging</a:t>
+                      </a:r>
+                    </a:p>
+                  </a:txBody>
+                  <a:tcPr>
+                    <a:solidFill>
+                      <a:srgbClr val="F2F6FB"/>
+                    </a:solidFill>
+                  </a:tcPr>
+                </a:tc>
+                <a:tc>
+                  <a:txBody>
+                    <a:bodyPr/>
+                    <a:lstStyle/>
+                    <a:p>
+                      <a:pPr>
+                        <a:defRPr sz="1200" b="0">
+                          <a:solidFill>
+                            <a:srgbClr val="1B1B2F"/>
+                          </a:solidFill>
+                        </a:defRPr>
+                      </a:pPr>
+                      <a:r>
+                        <a:t>Copilot CLI skills</a:t>
+                      </a:r>
+                    </a:p>
+                  </a:txBody>
+                  <a:tcPr>
+                    <a:solidFill>
+                      <a:srgbClr val="F2F6FB"/>
+                    </a:solidFill>
+                  </a:tcPr>
+                </a:tc>
+                <a:tc>
+                  <a:txBody>
+                    <a:bodyPr/>
+                    <a:lstStyle/>
+                    <a:p>
+                      <a:pPr>
+                        <a:defRPr sz="1200" b="0">
+                          <a:solidFill>
+                            <a:srgbClr val="1B1B2F"/>
+                          </a:solidFill>
+                        </a:defRPr>
+                      </a:pPr>
+                      <a:r>
+                        <a:t>Single FastAPI web app + unified CLI (skills retained)</a:t>
+                      </a:r>
+                    </a:p>
+                  </a:txBody>
+                  <a:tcPr>
+                    <a:solidFill>
+                      <a:srgbClr val="F2F6FB"/>
+                    </a:solidFill>
+                  </a:tcPr>
+                </a:tc>
+              </a:tr>
+              <a:tr h="449580">
+                <a:tc>
+                  <a:txBody>
+                    <a:bodyPr/>
+                    <a:lstStyle/>
+                    <a:p>
+                      <a:pPr>
+                        <a:defRPr sz="1200" b="0">
+                          <a:solidFill>
+                            <a:srgbClr val="1B1B2F"/>
+                          </a:solidFill>
+                        </a:defRPr>
+                      </a:pPr>
+                      <a:r>
+                        <a:t>Log decode</a:t>
+                      </a:r>
+                    </a:p>
+                  </a:txBody>
+                  <a:tcPr>
+                    <a:solidFill>
+                      <a:srgbClr val="FFFFFF"/>
+                    </a:solidFill>
+                  </a:tcPr>
+                </a:tc>
+                <a:tc>
+                  <a:txBody>
+                    <a:bodyPr/>
+                    <a:lstStyle/>
+                    <a:p>
+                      <a:pPr>
+                        <a:defRPr sz="1200" b="0">
+                          <a:solidFill>
+                            <a:srgbClr val="1B1B2F"/>
+                          </a:solidFill>
+                        </a:defRPr>
+                      </a:pPr>
+                      <a:r>
+                        <a:t>crash-parser</a:t>
+                      </a:r>
+                    </a:p>
+                  </a:txBody>
+                  <a:tcPr>
+                    <a:solidFill>
+                      <a:srgbClr val="FFFFFF"/>
+                    </a:solidFill>
+                  </a:tcPr>
+                </a:tc>
+                <a:tc>
+                  <a:txBody>
+                    <a:bodyPr/>
+                    <a:lstStyle/>
+                    <a:p>
+                      <a:pPr>
+                        <a:defRPr sz="1200" b="0">
+                          <a:solidFill>
+                            <a:srgbClr val="1B1B2F"/>
+                          </a:solidFill>
+                        </a:defRPr>
+                      </a:pPr>
+                      <a:r>
+                        <a:t>MCA / EWL / RC-Fatal / MCHECK / POST decoder DBs</a:t>
+                      </a:r>
+                    </a:p>
+                  </a:txBody>
+                  <a:tcPr>
+                    <a:solidFill>
+                      <a:srgbClr val="FFFFFF"/>
+                    </a:solidFill>
+                  </a:tcPr>
+                </a:tc>
+              </a:tr>
+              <a:tr h="449580">
+                <a:tc>
+                  <a:txBody>
+                    <a:bodyPr/>
+                    <a:lstStyle/>
+                    <a:p>
+                      <a:pPr>
+                        <a:defRPr sz="1200" b="0">
+                          <a:solidFill>
+                            <a:srgbClr val="1B1B2F"/>
+                          </a:solidFill>
+                        </a:defRPr>
+                      </a:pPr>
+                      <a:r>
+                        <a:t>Sources</a:t>
+                      </a:r>
+                    </a:p>
+                  </a:txBody>
+                  <a:tcPr>
+                    <a:solidFill>
+                      <a:srgbClr val="F2F6FB"/>
+                    </a:solidFill>
+                  </a:tcPr>
+                </a:tc>
+                <a:tc>
+                  <a:txBody>
+                    <a:bodyPr/>
+                    <a:lstStyle/>
+                    <a:p>
+                      <a:pPr>
+                        <a:defRPr sz="1200" b="0">
+                          <a:solidFill>
+                            <a:srgbClr val="1B1B2F"/>
+                          </a:solidFill>
+                        </a:defRPr>
+                      </a:pPr>
+                      <a:r>
+                        <a:t>-</a:t>
+                      </a:r>
+                    </a:p>
+                  </a:txBody>
+                  <a:tcPr>
+                    <a:solidFill>
+                      <a:srgbClr val="F2F6FB"/>
+                    </a:solidFill>
+                  </a:tcPr>
+                </a:tc>
+                <a:tc>
+                  <a:txBody>
+                    <a:bodyPr/>
+                    <a:lstStyle/>
+                    <a:p>
+                      <a:pPr>
+                        <a:defRPr sz="1200" b="0">
+                          <a:solidFill>
+                            <a:srgbClr val="1B1B2F"/>
+                          </a:solidFill>
+                        </a:defRPr>
+                      </a:pPr>
+                      <a:r>
+                        <a:t>Reference Sources table — cites every source used</a:t>
+                      </a:r>
+                    </a:p>
+                  </a:txBody>
+                  <a:tcPr>
+                    <a:solidFill>
+                      <a:srgbClr val="F2F6FB"/>
+                    </a:solidFill>
+                  </a:tcPr>
+                </a:tc>
+              </a:tr>
+              <a:tr h="449580">
+                <a:tc>
+                  <a:txBody>
+                    <a:bodyPr/>
+                    <a:lstStyle/>
+                    <a:p>
+                      <a:pPr>
+                        <a:defRPr sz="1200" b="0">
+                          <a:solidFill>
+                            <a:srgbClr val="1B1B2F"/>
+                          </a:solidFill>
+                        </a:defRPr>
+                      </a:pPr>
+                      <a:r>
+                        <a:t>Marketplace</a:t>
+                      </a:r>
+                    </a:p>
+                  </a:txBody>
+                  <a:tcPr>
+                    <a:solidFill>
+                      <a:srgbClr val="FFFFFF"/>
+                    </a:solidFill>
+                  </a:tcPr>
+                </a:tc>
+                <a:tc>
+                  <a:txBody>
+                    <a:bodyPr/>
+                    <a:lstStyle/>
+                    <a:p>
+                      <a:pPr>
+                        <a:defRPr sz="1200" b="0">
+                          <a:solidFill>
+                            <a:srgbClr val="1B1B2F"/>
+                          </a:solidFill>
+                        </a:defRPr>
+                      </a:pPr>
+                      <a:r>
+                        <a:t>-</a:t>
+                      </a:r>
+                    </a:p>
+                  </a:txBody>
+                  <a:tcPr>
+                    <a:solidFill>
+                      <a:srgbClr val="FFFFFF"/>
+                    </a:solidFill>
+                  </a:tcPr>
+                </a:tc>
+                <a:tc>
+                  <a:txBody>
+                    <a:bodyPr/>
+                    <a:lstStyle/>
+                    <a:p>
+                      <a:pPr>
+                        <a:defRPr sz="1200" b="0">
+                          <a:solidFill>
+                            <a:srgbClr val="1B1B2F"/>
+                          </a:solidFill>
+                        </a:defRPr>
+                      </a:pPr>
+                      <a:r>
+                        <a:t>Wiki KB (always) + BIOS/S3M, Kernel-crash, Redfish (need-based)</a:t>
+                      </a:r>
+                    </a:p>
+                  </a:txBody>
+                  <a:tcPr>
+                    <a:solidFill>
+                      <a:srgbClr val="FFFFFF"/>
+                    </a:solidFill>
+                  </a:tcPr>
+                </a:tc>
+              </a:tr>
+              <a:tr h="449580">
+                <a:tc>
+                  <a:txBody>
+                    <a:bodyPr/>
+                    <a:lstStyle/>
+                    <a:p>
+                      <a:pPr>
+                        <a:defRPr sz="1200" b="0">
+                          <a:solidFill>
+                            <a:srgbClr val="1B1B2F"/>
+                          </a:solidFill>
+                        </a:defRPr>
+                      </a:pPr>
+                      <a:r>
+                        <a:t>Live debug</a:t>
+                      </a:r>
+                    </a:p>
+                  </a:txBody>
+                  <a:tcPr>
+                    <a:solidFill>
+                      <a:srgbClr val="F2F6FB"/>
+                    </a:solidFill>
+                  </a:tcPr>
+                </a:tc>
+                <a:tc>
+                  <a:txBody>
+                    <a:bodyPr/>
+                    <a:lstStyle/>
+                    <a:p>
+                      <a:pPr>
+                        <a:defRPr sz="1200" b="0">
+                          <a:solidFill>
+                            <a:srgbClr val="1B1B2F"/>
+                          </a:solidFill>
+                        </a:defRPr>
+                      </a:pPr>
+                      <a:r>
+                        <a:t>SSH to SUT only</a:t>
+                      </a:r>
+                    </a:p>
+                  </a:txBody>
+                  <a:tcPr>
+                    <a:solidFill>
+                      <a:srgbClr val="F2F6FB"/>
+                    </a:solidFill>
+                  </a:tcPr>
+                </a:tc>
+                <a:tc>
+                  <a:txBody>
+                    <a:bodyPr/>
+                    <a:lstStyle/>
+                    <a:p>
+                      <a:pPr>
+                        <a:defRPr sz="1200" b="0">
+                          <a:solidFill>
+                            <a:srgbClr val="1B1B2F"/>
+                          </a:solidFill>
+                        </a:defRPr>
+                      </a:pPr>
+                      <a:r>
+                        <a:t>NUC PythonSV bridge — out-of-band when SUT is hung</a:t>
+                      </a:r>
+                    </a:p>
+                  </a:txBody>
+                  <a:tcPr>
+                    <a:solidFill>
+                      <a:srgbClr val="F2F6FB"/>
+                    </a:solidFill>
+                  </a:tcPr>
+                </a:tc>
+              </a:tr>
+              <a:tr h="449580">
+                <a:tc>
+                  <a:txBody>
+                    <a:bodyPr/>
+                    <a:lstStyle/>
+                    <a:p>
+                      <a:pPr>
+                        <a:defRPr sz="1200" b="0">
+                          <a:solidFill>
+                            <a:srgbClr val="1B1B2F"/>
+                          </a:solidFill>
+                        </a:defRPr>
+                      </a:pPr>
+                      <a:r>
+                        <a:t>Transport</a:t>
+                      </a:r>
+                    </a:p>
+                  </a:txBody>
+                  <a:tcPr>
+                    <a:solidFill>
+                      <a:srgbClr val="FFFFFF"/>
+                    </a:solidFill>
+                  </a:tcPr>
+                </a:tc>
+                <a:tc>
+                  <a:txBody>
+                    <a:bodyPr/>
+                    <a:lstStyle/>
+                    <a:p>
+                      <a:pPr>
+                        <a:defRPr sz="1200" b="0">
+                          <a:solidFill>
+                            <a:srgbClr val="1B1B2F"/>
+                          </a:solidFill>
+                        </a:defRPr>
+                      </a:pPr>
+                      <a:r>
+                        <a:t>SSH</a:t>
+                      </a:r>
+                    </a:p>
+                  </a:txBody>
+                  <a:tcPr>
+                    <a:solidFill>
+                      <a:srgbClr val="FFFFFF"/>
+                    </a:solidFill>
+                  </a:tcPr>
+                </a:tc>
+                <a:tc>
+                  <a:txBody>
+                    <a:bodyPr/>
+                    <a:lstStyle/>
+                    <a:p>
+                      <a:pPr>
+                        <a:defRPr sz="1200" b="0">
+                          <a:solidFill>
+                            <a:srgbClr val="1B1B2F"/>
+                          </a:solidFill>
+                        </a:defRPr>
+                      </a:pPr>
+                      <a:r>
+                        <a:t>SSH-first + WinRM fallback + setup popup</a:t>
+                      </a:r>
+                    </a:p>
+                  </a:txBody>
+                  <a:tcPr>
+                    <a:solidFill>
+                      <a:srgbClr val="FFFFFF"/>
+                    </a:solidFill>
+                  </a:tcPr>
+                </a:tc>
+              </a:tr>
+              <a:tr h="449580">
+                <a:tc>
+                  <a:txBody>
+                    <a:bodyPr/>
+                    <a:lstStyle/>
+                    <a:p>
+                      <a:pPr>
+                        <a:defRPr sz="1200" b="0">
+                          <a:solidFill>
+                            <a:srgbClr val="1B1B2F"/>
+                          </a:solidFill>
+                        </a:defRPr>
+                      </a:pPr>
+                      <a:r>
+                        <a:t>Secrets</a:t>
+                      </a:r>
+                    </a:p>
+                  </a:txBody>
+                  <a:tcPr>
+                    <a:solidFill>
+                      <a:srgbClr val="F2F6FB"/>
+                    </a:solidFill>
+                  </a:tcPr>
+                </a:tc>
+                <a:tc>
+                  <a:txBody>
+                    <a:bodyPr/>
+                    <a:lstStyle/>
+                    <a:p>
+                      <a:pPr>
+                        <a:defRPr sz="1200" b="0">
+                          <a:solidFill>
+                            <a:srgbClr val="1B1B2F"/>
+                          </a:solidFill>
+                        </a:defRPr>
+                      </a:pPr>
+                      <a:r>
+                        <a:t>SSH keys</a:t>
+                      </a:r>
+                    </a:p>
+                  </a:txBody>
+                  <a:tcPr>
+                    <a:solidFill>
+                      <a:srgbClr val="F2F6FB"/>
+                    </a:solidFill>
+                  </a:tcPr>
+                </a:tc>
+                <a:tc>
+                  <a:txBody>
+                    <a:bodyPr/>
+                    <a:lstStyle/>
+                    <a:p>
+                      <a:pPr>
+                        <a:defRPr sz="1200" b="0">
+                          <a:solidFill>
+                            <a:srgbClr val="1B1B2F"/>
+                          </a:solidFill>
+                        </a:defRPr>
+                      </a:pPr>
+                      <a:r>
+                        <a:t>UI password, masked, never stored; user auto-normalized</a:t>
+                      </a:r>
+                    </a:p>
+                  </a:txBody>
+                  <a:tcPr>
+                    <a:solidFill>
+                      <a:srgbClr val="F2F6FB"/>
+                    </a:solidFill>
+                  </a:tcPr>
+                </a:tc>
+              </a:tr>
+              <a:tr h="449580">
+                <a:tc>
+                  <a:txBody>
+                    <a:bodyPr/>
+                    <a:lstStyle/>
+                    <a:p>
+                      <a:pPr>
+                        <a:defRPr sz="1200" b="0">
+                          <a:solidFill>
+                            <a:srgbClr val="1B1B2F"/>
+                          </a:solidFill>
+                        </a:defRPr>
+                      </a:pPr>
+                      <a:r>
+                        <a:t>Session</a:t>
+                      </a:r>
+                    </a:p>
+                  </a:txBody>
+                  <a:tcPr>
+                    <a:solidFill>
+                      <a:srgbClr val="FFFFFF"/>
+                    </a:solidFill>
+                  </a:tcPr>
+                </a:tc>
+                <a:tc>
+                  <a:txBody>
+                    <a:bodyPr/>
+                    <a:lstStyle/>
+                    <a:p>
+                      <a:pPr>
+                        <a:defRPr sz="1200" b="0">
+                          <a:solidFill>
+                            <a:srgbClr val="1B1B2F"/>
+                          </a:solidFill>
+                        </a:defRPr>
+                      </a:pPr>
+                      <a:r>
+                        <a:t>one command</a:t>
+                      </a:r>
+                    </a:p>
+                  </a:txBody>
+                  <a:tcPr>
+                    <a:solidFill>
+                      <a:srgbClr val="FFFFFF"/>
+                    </a:solidFill>
+                  </a:tcPr>
+                </a:tc>
+                <a:tc>
+                  <a:txBody>
+                    <a:bodyPr/>
+                    <a:lstStyle/>
+                    <a:p>
+                      <a:pPr>
+                        <a:defRPr sz="1200" b="0">
+                          <a:solidFill>
+                            <a:srgbClr val="1B1B2F"/>
+                          </a:solidFill>
+                        </a:defRPr>
+                      </a:pPr>
+                      <a:r>
+                        <a:t>Persistent PythonSV session (imports/IPC persist)</a:t>
+                      </a:r>
+                    </a:p>
+                  </a:txBody>
+                  <a:tcPr>
+                    <a:solidFill>
+                      <a:srgbClr val="FFFFFF"/>
+                    </a:solidFill>
+                  </a:tcPr>
+                </a:tc>
+              </a:tr>
+              <a:tr h="449580">
+                <a:tc>
+                  <a:txBody>
+                    <a:bodyPr/>
+                    <a:lstStyle/>
+                    <a:p>
+                      <a:pPr>
+                        <a:defRPr sz="1200" b="0">
+                          <a:solidFill>
+                            <a:srgbClr val="1B1B2F"/>
+                          </a:solidFill>
+                        </a:defRPr>
+                      </a:pPr>
+                      <a:r>
+                        <a:t>Auto-fix</a:t>
+                      </a:r>
+                    </a:p>
+                  </a:txBody>
+                  <a:tcPr>
+                    <a:solidFill>
+                      <a:srgbClr val="F2F6FB"/>
+                    </a:solidFill>
+                  </a:tcPr>
+                </a:tc>
+                <a:tc>
+                  <a:txBody>
+                    <a:bodyPr/>
+                    <a:lstStyle/>
+                    <a:p>
+                      <a:pPr>
+                        <a:defRPr sz="1200" b="0">
+                          <a:solidFill>
+                            <a:srgbClr val="1B1B2F"/>
+                          </a:solidFill>
+                        </a:defRPr>
+                      </a:pPr>
+                      <a:r>
+                        <a:t>-</a:t>
+                      </a:r>
+                    </a:p>
+                  </a:txBody>
+                  <a:tcPr>
+                    <a:solidFill>
+                      <a:srgbClr val="F2F6FB"/>
+                    </a:solidFill>
+                  </a:tcPr>
+                </a:tc>
+                <a:tc>
+                  <a:txBody>
+                    <a:bodyPr/>
+                    <a:lstStyle/>
+                    <a:p>
+                      <a:pPr>
+                        <a:defRPr sz="1200" b="0">
+                          <a:solidFill>
+                            <a:srgbClr val="1B1B2F"/>
+                          </a:solidFill>
+                        </a:defRPr>
+                      </a:pPr>
+                      <a:r>
+                        <a:t>Auto-init unlock + refresh; skippable</a:t>
+                      </a:r>
+                    </a:p>
+                  </a:txBody>
+                  <a:tcPr>
+                    <a:solidFill>
+                      <a:srgbClr val="F2F6FB"/>
+                    </a:solidFill>
+                  </a:tcPr>
+                </a:tc>
+              </a:tr>
+              <a:tr h="449580">
+                <a:tc>
+                  <a:txBody>
+                    <a:bodyPr/>
+                    <a:lstStyle/>
+                    <a:p>
+                      <a:pPr>
+                        <a:defRPr sz="1200" b="0">
+                          <a:solidFill>
+                            <a:srgbClr val="1B1B2F"/>
+                          </a:solidFill>
+                        </a:defRPr>
+                      </a:pPr>
+                      <a:r>
+                        <a:t>Readability</a:t>
+                      </a:r>
+                    </a:p>
+                  </a:txBody>
+                  <a:tcPr>
+                    <a:solidFill>
+                      <a:srgbClr val="FFFFFF"/>
+                    </a:solidFill>
+                  </a:tcPr>
+                </a:tc>
+                <a:tc>
+                  <a:txBody>
+                    <a:bodyPr/>
+                    <a:lstStyle/>
+                    <a:p>
+                      <a:pPr>
+                        <a:defRPr sz="1200" b="0">
+                          <a:solidFill>
+                            <a:srgbClr val="1B1B2F"/>
+                          </a:solidFill>
+                        </a:defRPr>
+                      </a:pPr>
+                      <a:r>
+                        <a:t>raw dump</a:t>
+                      </a:r>
+                    </a:p>
+                  </a:txBody>
+                  <a:tcPr>
+                    <a:solidFill>
+                      <a:srgbClr val="FFFFFF"/>
+                    </a:solidFill>
+                  </a:tcPr>
+                </a:tc>
+                <a:tc>
+                  <a:txBody>
+                    <a:bodyPr/>
+                    <a:lstStyle/>
+                    <a:p>
+                      <a:pPr>
+                        <a:defRPr sz="1200" b="0">
+                          <a:solidFill>
+                            <a:srgbClr val="1B1B2F"/>
+                          </a:solidFill>
+                        </a:defRPr>
+                      </a:pPr>
+                      <a:r>
+                        <a:t>Output cleaner + state interpreter notes</a:t>
+                      </a:r>
+                    </a:p>
+                  </a:txBody>
+                  <a:tcPr>
+                    <a:solidFill>
+                      <a:srgbClr val="FFFFFF"/>
+                    </a:solidFill>
+                  </a:tcPr>
+                </a:tc>
+              </a:tr>
+              <a:tr h="449580">
+                <a:tc>
+                  <a:txBody>
+                    <a:bodyPr/>
+                    <a:lstStyle/>
+                    <a:p>
+                      <a:pPr>
+                        <a:defRPr sz="1200" b="0">
+                          <a:solidFill>
+                            <a:srgbClr val="1B1B2F"/>
+                          </a:solidFill>
+                        </a:defRPr>
+                      </a:pPr>
+                      <a:r>
+                        <a:t>Validation</a:t>
+                      </a:r>
+                    </a:p>
+                  </a:txBody>
+                  <a:tcPr>
+                    <a:solidFill>
+                      <a:srgbClr val="F2F6FB"/>
+                    </a:solidFill>
+                  </a:tcPr>
+                </a:tc>
+                <a:tc>
+                  <a:txBody>
+                    <a:bodyPr/>
+                    <a:lstStyle/>
+                    <a:p>
+                      <a:pPr>
+                        <a:defRPr sz="1200" b="0">
+                          <a:solidFill>
+                            <a:srgbClr val="1B1B2F"/>
+                          </a:solidFill>
+                        </a:defRPr>
+                      </a:pPr>
+                      <a:r>
+                        <a:t>-</a:t>
+                      </a:r>
+                    </a:p>
+                  </a:txBody>
+                  <a:tcPr>
+                    <a:solidFill>
+                      <a:srgbClr val="F2F6FB"/>
+                    </a:solidFill>
+                  </a:tcPr>
+                </a:tc>
+                <a:tc>
+                  <a:txBody>
+                    <a:bodyPr/>
+                    <a:lstStyle/>
+                    <a:p>
+                      <a:pPr>
+                        <a:defRPr sz="1200" b="0">
+                          <a:solidFill>
+                            <a:srgbClr val="1B1B2F"/>
+                          </a:solidFill>
+                        </a:defRPr>
+                      </a:pPr>
+                      <a:r>
+                        <a:t>Unified smoke test (15 checks)</a:t>
+                      </a:r>
+                    </a:p>
+                  </a:txBody>
+                  <a:tcPr>
+                    <a:solidFill>
+                      <a:srgbClr val="F2F6FB"/>
+                    </a:solidFill>
+                  </a:tcPr>
+                </a:tc>
+              </a:tr>
+            </a:tbl>
+          </a:graphicData>
+        </a:graphic>
+      </p:graphicFrame>
+    </p:spTree>
+  </p:cSld>
+  <p:clrMapOvr>
+    <a:masterClrMapping/>
+  </p:clrMapOvr>
+</p:sld>
+</file>
+
+<file path=ppt/slides/slide19.xml><?xml version="1.0" encoding="utf-8"?>
+<p:sld xmlns:a="http://schemas.openxmlformats.org/drawingml/2006/main" xmlns:p="http://schemas.openxmlformats.org/presentationml/2006/main" xmlns:r="http://schemas.openxmlformats.org/officeDocument/2006/relationships">
+  <p:cSld>
+    <p:spTree>
+      <p:nvGrpSpPr>
+        <p:cNvPr id="1" name=""/>
+        <p:cNvGrpSpPr/>
+        <p:nvPr/>
+      </p:nvGrpSpPr>
+      <p:grpSpPr/>
+      <p:sp>
+        <p:nvSpPr>
+          <p:cNvPr id="2" name="Rectangle 1"/>
+          <p:cNvSpPr/>
+          <p:nvPr/>
+        </p:nvSpPr>
+        <p:spPr>
+          <a:xfrm>
+            <a:off x="0" y="0"/>
+            <a:ext cx="12192000" cy="960120"/>
+          </a:xfrm>
+          <a:prstGeom prst="rect">
+            <a:avLst/>
+          </a:prstGeom>
+          <a:solidFill>
+            <a:srgbClr val="0071C5"/>
+          </a:solidFill>
+          <a:ln>
+            <a:noFill/>
+          </a:ln>
+        </p:spPr>
+        <p:style>
+          <a:lnRef idx="1">
+            <a:schemeClr val="accent1"/>
+          </a:lnRef>
+          <a:fillRef idx="3">
+            <a:schemeClr val="accent1"/>
+          </a:fillRef>
+          <a:effectRef idx="2">
+            <a:schemeClr val="accent1"/>
+          </a:effectRef>
+          <a:fontRef idx="minor">
+            <a:schemeClr val="lt1"/>
+          </a:fontRef>
+        </p:style>
+        <p:txBody>
+          <a:bodyPr rtlCol="0" anchor="ctr" lIns="365760" wrap="square"/>
+          <a:lstStyle/>
+          <a:p>
+            <a:pPr algn="ctr">
+              <a:defRPr sz="3000" b="1">
+                <a:solidFill>
+                  <a:srgbClr val="FFFFFF"/>
+                </a:solidFill>
+              </a:defRPr>
+            </a:pPr>
+            <a:r>
+              <a:t>Feature spotlight — PythonSV Live Debug via NUC</a:t>
+            </a:r>
+          </a:p>
+          <a:p>
+            <a:pPr>
+              <a:defRPr sz="1400">
+                <a:solidFill>
+                  <a:srgbClr val="DCEBFA"/>
+                </a:solidFill>
+              </a:defRPr>
+            </a:pPr>
+            <a:r>
+              <a:t>Debug a hung node when SSH to the SUT is impossible</a:t>
+            </a:r>
+          </a:p>
+        </p:txBody>
+      </p:sp>
+      <p:sp>
+        <p:nvSpPr>
+          <p:cNvPr id="3" name="TextBox 2"/>
+          <p:cNvSpPr txBox="1"/>
+          <p:nvPr/>
+        </p:nvSpPr>
+        <p:spPr>
+          <a:xfrm>
+            <a:off x="548640" y="1280160"/>
+            <a:ext cx="11064240" cy="5212080"/>
+          </a:xfrm>
+          <a:prstGeom prst="rect">
+            <a:avLst/>
+          </a:prstGeom>
+          <a:noFill/>
+        </p:spPr>
+        <p:txBody>
+          <a:bodyPr wrap="square">
+            <a:spAutoFit/>
+          </a:bodyPr>
+          <a:lstStyle/>
+          <a:p>
+            <a:pPr>
+              <a:spcAft>
+                <a:spcPts val="600"/>
+              </a:spcAft>
+              <a:defRPr sz="1600">
+                <a:solidFill>
+                  <a:srgbClr val="1B1B2F"/>
+                </a:solidFill>
+              </a:defRPr>
+            </a:pPr>
+            <a:r>
+              <a:t>Problem: when the SUT is hung/failed, you cannot SSH in to run live debug.</a:t>
+            </a:r>
+          </a:p>
+          <a:p>
+            <a:pPr>
+              <a:spcAft>
+                <a:spcPts val="600"/>
+              </a:spcAft>
+              <a:defRPr sz="1600">
+                <a:solidFill>
+                  <a:srgbClr val="1B1B2F"/>
+                </a:solidFill>
+              </a:defRPr>
+            </a:pPr>
+            <a:r>
+              <a:t>Solution: connect to the bench NUC (Windows + PythonSV) that keeps ITP/sideband access to the SUT.</a:t>
+            </a:r>
+          </a:p>
+          <a:p>
+            <a:pPr>
+              <a:spcAft>
+                <a:spcPts val="600"/>
+              </a:spcAft>
+              <a:defRPr sz="1600">
+                <a:solidFill>
+                  <a:srgbClr val="1B1B2F"/>
+                </a:solidFill>
+              </a:defRPr>
+            </a:pPr>
+            <a:r>
+              <a:t>Dual transport: tries SSH first, falls back to WinRM; if neither is ready, a popup shows the one-time WinRM setup.</a:t>
+            </a:r>
+          </a:p>
+          <a:p>
+            <a:pPr>
+              <a:spcAft>
+                <a:spcPts val="600"/>
+              </a:spcAft>
+              <a:defRPr sz="1600">
+                <a:solidFill>
+                  <a:srgbClr val="1B1B2F"/>
+                </a:solidFill>
+              </a:defRPr>
+            </a:pPr>
+            <a:r>
+              <a:t>Dedicated PythonSV tab: enter NUC host/user/password (masked); Connect / Probe verifies host + C:\pythonsv.</a:t>
+            </a:r>
+          </a:p>
+          <a:p>
+            <a:pPr>
+              <a:spcAft>
+                <a:spcPts val="600"/>
+              </a:spcAft>
+              <a:defRPr sz="1600">
+                <a:solidFill>
+                  <a:srgbClr val="1B1B2F"/>
+                </a:solidFill>
+              </a:defRPr>
+            </a:pPr>
+            <a:r>
+              <a:t>Runs your commands in ONE persistent session so sv, ipc, and imports stay alive across lines.</a:t>
+            </a:r>
+          </a:p>
+          <a:p>
+            <a:pPr>
+              <a:spcAft>
+                <a:spcPts val="600"/>
+              </a:spcAft>
+              <a:defRPr sz="1600">
+                <a:solidFill>
+                  <a:srgbClr val="1B1B2F"/>
+                </a:solidFill>
+              </a:defRPr>
+            </a:pPr>
+            <a:r>
+              <a:t>Auto-detects &amp; explains PythonSV states: part LOCKED -&gt; auto unlock; NOT out of reset; pcode bring-up not started; undefined helper; missing module; SUT no-ping.</a:t>
+            </a:r>
+          </a:p>
+          <a:p>
+            <a:pPr>
+              <a:spcAft>
+                <a:spcPts val="600"/>
+              </a:spcAft>
+              <a:defRPr sz="1600">
+                <a:solidFill>
+                  <a:srgbClr val="1B1B2F"/>
+                </a:solidFill>
+              </a:defRPr>
+            </a:pPr>
+            <a:r>
+              <a:t>Output cleaned (EOL banner, version table, per-IP init noise removed) and annotated with readable Notes.</a:t>
+            </a:r>
+          </a:p>
+        </p:txBody>
+      </p:sp>
+    </p:spTree>
+  </p:cSld>
+  <p:clrMapOvr>
+    <a:masterClrMapping/>
+  </p:clrMapOvr>
+</p:sld>
+</file>
+
 <file path=ppt/slides/slide2.xml><?xml version="1.0" encoding="utf-8"?>
 <p:sld xmlns:a="http://schemas.openxmlformats.org/drawingml/2006/main" xmlns:r="http://schemas.openxmlformats.org/officeDocument/2006/relationships" xmlns:p="http://schemas.openxmlformats.org/presentationml/2006/main">
   <p:cSld>
@@ -4554,6 +7186,377 @@
             <a:r>
               <a:rPr dirty="0"/>
               <a:t>Net: hours per ticket, uneven quality, and re-investigation of already-solved issues.</a:t>
+            </a:r>
+          </a:p>
+        </p:txBody>
+      </p:sp>
+    </p:spTree>
+  </p:cSld>
+  <p:clrMapOvr>
+    <a:masterClrMapping/>
+  </p:clrMapOvr>
+</p:sld>
+</file>
+
+<file path=ppt/slides/slide20.xml><?xml version="1.0" encoding="utf-8"?>
+<p:sld xmlns:a="http://schemas.openxmlformats.org/drawingml/2006/main" xmlns:p="http://schemas.openxmlformats.org/presentationml/2006/main" xmlns:r="http://schemas.openxmlformats.org/officeDocument/2006/relationships">
+  <p:cSld>
+    <p:spTree>
+      <p:nvGrpSpPr>
+        <p:cNvPr id="1" name=""/>
+        <p:cNvGrpSpPr/>
+        <p:nvPr/>
+      </p:nvGrpSpPr>
+      <p:grpSpPr/>
+      <p:sp>
+        <p:nvSpPr>
+          <p:cNvPr id="2" name="Rectangle 1"/>
+          <p:cNvSpPr/>
+          <p:nvPr/>
+        </p:nvSpPr>
+        <p:spPr>
+          <a:xfrm>
+            <a:off x="0" y="0"/>
+            <a:ext cx="12192000" cy="960120"/>
+          </a:xfrm>
+          <a:prstGeom prst="rect">
+            <a:avLst/>
+          </a:prstGeom>
+          <a:solidFill>
+            <a:srgbClr val="0071C5"/>
+          </a:solidFill>
+          <a:ln>
+            <a:noFill/>
+          </a:ln>
+        </p:spPr>
+        <p:style>
+          <a:lnRef idx="1">
+            <a:schemeClr val="accent1"/>
+          </a:lnRef>
+          <a:fillRef idx="3">
+            <a:schemeClr val="accent1"/>
+          </a:fillRef>
+          <a:effectRef idx="2">
+            <a:schemeClr val="accent1"/>
+          </a:effectRef>
+          <a:fontRef idx="minor">
+            <a:schemeClr val="lt1"/>
+          </a:fontRef>
+        </p:style>
+        <p:txBody>
+          <a:bodyPr rtlCol="0" anchor="ctr" lIns="365760" wrap="square"/>
+          <a:lstStyle/>
+          <a:p>
+            <a:pPr algn="ctr">
+              <a:defRPr sz="3000" b="1">
+                <a:solidFill>
+                  <a:srgbClr val="FFFFFF"/>
+                </a:solidFill>
+              </a:defRPr>
+            </a:pPr>
+            <a:r>
+              <a:t>In action — flow &amp; report</a:t>
+            </a:r>
+          </a:p>
+        </p:txBody>
+      </p:sp>
+      <p:pic>
+        <p:nvPicPr>
+          <p:cNvPr id="3" name="Picture 2" descr="image.png"/>
+          <p:cNvPicPr>
+            <a:picLocks noChangeAspect="1"/>
+          </p:cNvPicPr>
+          <p:nvPr/>
+        </p:nvPicPr>
+        <p:blipFill>
+          <a:blip r:embed="rId2"/>
+          <a:stretch>
+            <a:fillRect/>
+          </a:stretch>
+        </p:blipFill>
+        <p:spPr>
+          <a:xfrm>
+            <a:off x="365760" y="1188720"/>
+            <a:ext cx="9053330" cy="5120640"/>
+          </a:xfrm>
+          <a:prstGeom prst="rect">
+            <a:avLst/>
+          </a:prstGeom>
+        </p:spPr>
+      </p:pic>
+      <p:pic>
+        <p:nvPicPr>
+          <p:cNvPr id="4" name="Picture 3" descr="image.png"/>
+          <p:cNvPicPr>
+            <a:picLocks noChangeAspect="1"/>
+          </p:cNvPicPr>
+          <p:nvPr/>
+        </p:nvPicPr>
+        <p:blipFill>
+          <a:blip r:embed="rId3"/>
+          <a:stretch>
+            <a:fillRect/>
+          </a:stretch>
+        </p:blipFill>
+        <p:spPr>
+          <a:xfrm>
+            <a:off x="6309360" y="1188720"/>
+            <a:ext cx="6422498" cy="5120640"/>
+          </a:xfrm>
+          <a:prstGeom prst="rect">
+            <a:avLst/>
+          </a:prstGeom>
+        </p:spPr>
+      </p:pic>
+      <p:sp>
+        <p:nvSpPr>
+          <p:cNvPr id="5" name="TextBox 4"/>
+          <p:cNvSpPr txBox="1"/>
+          <p:nvPr/>
+        </p:nvSpPr>
+        <p:spPr>
+          <a:xfrm>
+            <a:off x="365760" y="6355080"/>
+            <a:ext cx="11430000" cy="365760"/>
+          </a:xfrm>
+          <a:prstGeom prst="rect">
+            <a:avLst/>
+          </a:prstGeom>
+          <a:noFill/>
+        </p:spPr>
+        <p:txBody>
+          <a:bodyPr wrap="square">
+            <a:spAutoFit/>
+          </a:bodyPr>
+          <a:lstStyle/>
+          <a:p>
+            <a:pPr>
+              <a:defRPr sz="1200">
+                <a:solidFill>
+                  <a:srgbClr val="5A6372"/>
+                </a:solidFill>
+              </a:defRPr>
+            </a:pPr>
+            <a:r>
+              <a:t>Left: analysis flow   ·   Right: generated RCA report (Markdown + HTML)</a:t>
+            </a:r>
+          </a:p>
+        </p:txBody>
+      </p:sp>
+    </p:spTree>
+  </p:cSld>
+  <p:clrMapOvr>
+    <a:masterClrMapping/>
+  </p:clrMapOvr>
+</p:sld>
+</file>
+
+<file path=ppt/slides/slide21.xml><?xml version="1.0" encoding="utf-8"?>
+<p:sld xmlns:a="http://schemas.openxmlformats.org/drawingml/2006/main" xmlns:p="http://schemas.openxmlformats.org/presentationml/2006/main" xmlns:r="http://schemas.openxmlformats.org/officeDocument/2006/relationships">
+  <p:cSld>
+    <p:spTree>
+      <p:nvGrpSpPr>
+        <p:cNvPr id="1" name=""/>
+        <p:cNvGrpSpPr/>
+        <p:nvPr/>
+      </p:nvGrpSpPr>
+      <p:grpSpPr/>
+      <p:sp>
+        <p:nvSpPr>
+          <p:cNvPr id="2" name="Rectangle 1"/>
+          <p:cNvSpPr/>
+          <p:nvPr/>
+        </p:nvSpPr>
+        <p:spPr>
+          <a:xfrm>
+            <a:off x="0" y="0"/>
+            <a:ext cx="12192000" cy="960120"/>
+          </a:xfrm>
+          <a:prstGeom prst="rect">
+            <a:avLst/>
+          </a:prstGeom>
+          <a:solidFill>
+            <a:srgbClr val="0071C5"/>
+          </a:solidFill>
+          <a:ln>
+            <a:noFill/>
+          </a:ln>
+        </p:spPr>
+        <p:style>
+          <a:lnRef idx="1">
+            <a:schemeClr val="accent1"/>
+          </a:lnRef>
+          <a:fillRef idx="3">
+            <a:schemeClr val="accent1"/>
+          </a:fillRef>
+          <a:effectRef idx="2">
+            <a:schemeClr val="accent1"/>
+          </a:effectRef>
+          <a:fontRef idx="minor">
+            <a:schemeClr val="lt1"/>
+          </a:fontRef>
+        </p:style>
+        <p:txBody>
+          <a:bodyPr rtlCol="0" anchor="ctr" lIns="365760" wrap="square"/>
+          <a:lstStyle/>
+          <a:p>
+            <a:pPr algn="ctr">
+              <a:defRPr sz="3000" b="1">
+                <a:solidFill>
+                  <a:srgbClr val="FFFFFF"/>
+                </a:solidFill>
+              </a:defRPr>
+            </a:pPr>
+            <a:r>
+              <a:t>Security, and current status</a:t>
+            </a:r>
+          </a:p>
+        </p:txBody>
+      </p:sp>
+      <p:sp>
+        <p:nvSpPr>
+          <p:cNvPr id="3" name="TextBox 2"/>
+          <p:cNvSpPr txBox="1"/>
+          <p:nvPr/>
+        </p:nvSpPr>
+        <p:spPr>
+          <a:xfrm>
+            <a:off x="548640" y="1280160"/>
+            <a:ext cx="11064240" cy="4937760"/>
+          </a:xfrm>
+          <a:prstGeom prst="rect">
+            <a:avLst/>
+          </a:prstGeom>
+          <a:noFill/>
+        </p:spPr>
+        <p:txBody>
+          <a:bodyPr wrap="square">
+            <a:spAutoFit/>
+          </a:bodyPr>
+          <a:lstStyle/>
+          <a:p>
+            <a:pPr>
+              <a:spcAft>
+                <a:spcPts val="600"/>
+              </a:spcAft>
+              <a:defRPr sz="1800">
+                <a:solidFill>
+                  <a:srgbClr val="1B1B2F"/>
+                </a:solidFill>
+              </a:defRPr>
+            </a:pPr>
+            <a:r>
+              <a:t>Secrets: NUC password used only for the connection — masked in all output, never written to disk or logs.</a:t>
+            </a:r>
+          </a:p>
+          <a:p>
+            <a:pPr>
+              <a:spcAft>
+                <a:spcPts val="600"/>
+              </a:spcAft>
+              <a:defRPr sz="1800">
+                <a:solidFill>
+                  <a:srgbClr val="1B1B2F"/>
+                </a:solidFill>
+              </a:defRPr>
+            </a:pPr>
+            <a:r>
+              <a:t>Enrichment sources are OFF unless configured; failures are skipped and never block core analysis.</a:t>
+            </a:r>
+          </a:p>
+          <a:p>
+            <a:pPr>
+              <a:spcAft>
+                <a:spcPts val="600"/>
+              </a:spcAft>
+              <a:defRPr sz="1800">
+                <a:solidFill>
+                  <a:srgbClr val="1B1B2F"/>
+                </a:solidFill>
+              </a:defRPr>
+            </a:pPr>
+            <a:r>
+              <a:t>Kerberos SSO to HSDES (no token/password) for on-domain users.</a:t>
+            </a:r>
+          </a:p>
+          <a:p>
+            <a:pPr>
+              <a:spcAft>
+                <a:spcPts val="600"/>
+              </a:spcAft>
+              <a:defRPr sz="1800">
+                <a:solidFill>
+                  <a:srgbClr val="1B1B2F"/>
+                </a:solidFill>
+              </a:defRPr>
+            </a:pPr>
+            <a:r>
+              <a:t>Validated live: SSH connect + persistent session confirmed against a real 2S GNR NUC; part unlocked, 37 IPs enumerated.</a:t>
+            </a:r>
+          </a:p>
+          <a:p>
+            <a:pPr>
+              <a:spcAft>
+                <a:spcPts val="600"/>
+              </a:spcAft>
+              <a:defRPr sz="1800">
+                <a:solidFill>
+                  <a:srgbClr val="1B1B2F"/>
+                </a:solidFill>
+              </a:defRPr>
+            </a:pPr>
+            <a:r>
+              <a:t>Unified smoke test: 15 / 15 passing.</a:t>
+            </a:r>
+          </a:p>
+          <a:p>
+            <a:pPr>
+              <a:spcAft>
+                <a:spcPts val="600"/>
+              </a:spcAft>
+              <a:defRPr sz="1800">
+                <a:solidFill>
+                  <a:srgbClr val="1B1B2F"/>
+                </a:solidFill>
+              </a:defRPr>
+            </a:pPr>
+            <a:r>
+              <a:t>Published to intel-sandbox/BugScout (PR) and mirrored to the personal repo.</a:t>
+            </a:r>
+          </a:p>
+        </p:txBody>
+      </p:sp>
+      <p:sp>
+        <p:nvSpPr>
+          <p:cNvPr id="4" name="TextBox 3"/>
+          <p:cNvSpPr txBox="1"/>
+          <p:nvPr/>
+        </p:nvSpPr>
+        <p:spPr>
+          <a:xfrm>
+            <a:off x="548640" y="5852160"/>
+            <a:ext cx="10972800" cy="640080"/>
+          </a:xfrm>
+          <a:prstGeom prst="rect">
+            <a:avLst/>
+          </a:prstGeom>
+          <a:noFill/>
+        </p:spPr>
+        <p:txBody>
+          <a:bodyPr wrap="square">
+            <a:spAutoFit/>
+          </a:bodyPr>
+          <a:lstStyle/>
+          <a:p>
+            <a:pPr>
+              <a:defRPr sz="2000" b="1">
+                <a:solidFill>
+                  <a:srgbClr val="2E7D32"/>
+                </a:solidFill>
+              </a:defRPr>
+            </a:pPr>
+            <a:r>
+              <a:t>Status: demo-ready</a:t>
             </a:r>
           </a:p>
         </p:txBody>

</xml_diff>